<commit_message>
deck refinement: deeper palette + de-pink + preview/pptx parity + note-faithful content restore
① 主色再加深 (#46196B 深清华紫) + 各色 _L 调深；图/框图改深色实填：原生框图关键框用 solid 饱和填白字 (pnr 四任务 / loop 四环 / hier flat / pnr 高亮)，SOFT 卡片底改取深 _L (单一真源)，不再粉/浅
〇 预览端 _fit_scale 模拟 PowerPoint shrink-to-fit：内容过满时按比例缩字号渲染 → 预览≈导出 pptx，校对才准 (split/bullets/cols2)
② 按笔记逐节比对 (5-章并行审校 workflow)，补回过度精简页：1.1/1.5/2.1/2.4/2.6/2.7/3.2/5.1 还原对自学重要的要点 (完整句、忠于笔记)
③ 4.5 稀疏表 2→3 列 (结构/所在层位置/作用)，把横向空间用起来

Co-Authored-By: Claude Opus 4.8 <noreply@anthropic.com>
</commit_message>
<xml_diff>
--- a/IC_Backend_Notes/slides/05_Floorplan - 副本.pptx
+++ b/IC_Backend_Notes/slides/05_Floorplan - 副本.pptx
@@ -38,6 +38,7 @@
     <p:sldId id="286" r:id="rId37"/>
     <p:sldId id="287" r:id="rId38"/>
     <p:sldId id="288" r:id="rId39"/>
+    <p:sldId id="289" r:id="rId40"/>
   </p:sldIdLst>
   <p:sldSz cx="12191695" cy="6858000" type="screen4x3"/>
   <p:notesSz cx="6858000" cy="9144000"/>
@@ -171,7 +172,7 @@
             <a:avLst/>
           </a:prstGeom>
           <a:solidFill>
-            <a:srgbClr val="1D4ED8"/>
+            <a:srgbClr val="46196B"/>
           </a:solidFill>
           <a:ln>
             <a:noFill/>
@@ -661,7 +662,7 @@
             <a:avLst/>
           </a:prstGeom>
           <a:solidFill>
-            <a:srgbClr val="1D4ED8"/>
+            <a:srgbClr val="46196B"/>
           </a:solidFill>
           <a:ln>
             <a:noFill/>
@@ -720,7 +721,7 @@
             <a:r>
               <a:rPr sz="1400" b="1">
                 <a:solidFill>
-                  <a:srgbClr val="1D4ED8"/>
+                  <a:srgbClr val="46196B"/>
                 </a:solidFill>
                 <a:latin typeface="Microsoft YaHei"/>
                 <a:ea typeface="Microsoft YaHei"/>
@@ -828,7 +829,7 @@
             <a:avLst/>
           </a:prstGeom>
           <a:solidFill>
-            <a:srgbClr val="1D4ED8"/>
+            <a:srgbClr val="46196B"/>
           </a:solidFill>
           <a:ln>
             <a:noFill/>
@@ -887,7 +888,7 @@
             <a:r>
               <a:rPr sz="1400" b="1">
                 <a:solidFill>
-                  <a:srgbClr val="EA580C"/>
+                  <a:srgbClr val="D14E0A"/>
                 </a:solidFill>
                 <a:latin typeface="Microsoft YaHei"/>
                 <a:ea typeface="Microsoft YaHei"/>
@@ -1069,7 +1070,7 @@
             <a:r>
               <a:rPr sz="1200" b="1">
                 <a:solidFill>
-                  <a:srgbClr val="1D4ED8"/>
+                  <a:srgbClr val="46196B"/>
                 </a:solidFill>
                 <a:latin typeface="Microsoft YaHei"/>
                 <a:ea typeface="Microsoft YaHei"/>
@@ -1255,7 +1256,7 @@
           <a:lstStyle/>
           <a:p>
             <a:pPr algn="r"/>
-            <a:fld id="{53C74F42-B7B0-4985-B475-6F2C860A82DA}" type="slidenum">
+            <a:fld id="{0079DE82-EF36-44CF-8CB6-342409976418}" type="slidenum">
               <a:rPr lang="en-US" sz="1000">
                 <a:solidFill>
                   <a:srgbClr val="9AA3B0"/>
@@ -1397,7 +1398,7 @@
             <a:r>
               <a:rPr sz="1200" b="1">
                 <a:solidFill>
-                  <a:srgbClr val="1D4ED8"/>
+                  <a:srgbClr val="46196B"/>
                 </a:solidFill>
                 <a:latin typeface="Microsoft YaHei"/>
                 <a:ea typeface="Microsoft YaHei"/>
@@ -1541,7 +1542,7 @@
           <a:lstStyle/>
           <a:p>
             <a:pPr algn="r"/>
-            <a:fld id="{DF4D5A3E-B567-42AC-A1AB-DA62ACE1DC73}" type="slidenum">
+            <a:fld id="{E64BCFDA-D2BD-434E-B449-9893058B7BDF}" type="slidenum">
               <a:rPr lang="en-US" sz="1000">
                 <a:solidFill>
                   <a:srgbClr val="9AA3B0"/>
@@ -1683,7 +1684,7 @@
             <a:r>
               <a:rPr sz="1200" b="1">
                 <a:solidFill>
-                  <a:srgbClr val="1D4ED8"/>
+                  <a:srgbClr val="46196B"/>
                 </a:solidFill>
                 <a:latin typeface="Microsoft YaHei"/>
                 <a:ea typeface="Microsoft YaHei"/>
@@ -1856,11 +1857,11 @@
             </a:avLst>
           </a:prstGeom>
           <a:solidFill>
-            <a:srgbClr val="DBEAFE"/>
+            <a:srgbClr val="D4C2E5"/>
           </a:solidFill>
           <a:ln w="19050">
             <a:solidFill>
-              <a:srgbClr val="1D4ED8"/>
+              <a:srgbClr val="46196B"/>
             </a:solidFill>
           </a:ln>
           <a:effectLst/>
@@ -1887,7 +1888,7 @@
             <a:r>
               <a:rPr sz="1300" b="1">
                 <a:solidFill>
-                  <a:srgbClr val="1E3A8A"/>
+                  <a:srgbClr val="2C0E48"/>
                 </a:solidFill>
                 <a:latin typeface="Microsoft YaHei"/>
                 <a:ea typeface="Microsoft YaHei"/>
@@ -1915,11 +1916,11 @@
             </a:avLst>
           </a:prstGeom>
           <a:solidFill>
-            <a:srgbClr val="DBEAFE"/>
+            <a:srgbClr val="D4C2E5"/>
           </a:solidFill>
           <a:ln w="19050">
             <a:solidFill>
-              <a:srgbClr val="1D4ED8"/>
+              <a:srgbClr val="46196B"/>
             </a:solidFill>
           </a:ln>
           <a:effectLst/>
@@ -1946,7 +1947,7 @@
             <a:r>
               <a:rPr sz="1300" b="1">
                 <a:solidFill>
-                  <a:srgbClr val="1E3A8A"/>
+                  <a:srgbClr val="2C0E48"/>
                 </a:solidFill>
                 <a:latin typeface="Microsoft YaHei"/>
                 <a:ea typeface="Microsoft YaHei"/>
@@ -1974,11 +1975,11 @@
             </a:avLst>
           </a:prstGeom>
           <a:solidFill>
-            <a:srgbClr val="CCFBF1"/>
+            <a:srgbClr val="9FE2D4"/>
           </a:solidFill>
           <a:ln w="19050">
             <a:solidFill>
-              <a:srgbClr val="0D9488"/>
+              <a:srgbClr val="0B7D72"/>
             </a:solidFill>
           </a:ln>
           <a:effectLst/>
@@ -2005,7 +2006,7 @@
             <a:r>
               <a:rPr sz="1300" b="1">
                 <a:solidFill>
-                  <a:srgbClr val="115E59"/>
+                  <a:srgbClr val="084A43"/>
                 </a:solidFill>
                 <a:latin typeface="Microsoft YaHei"/>
                 <a:ea typeface="Microsoft YaHei"/>
@@ -2033,11 +2034,11 @@
             </a:avLst>
           </a:prstGeom>
           <a:solidFill>
-            <a:srgbClr val="FEE2E2"/>
+            <a:srgbClr val="E6ADAD"/>
           </a:solidFill>
           <a:ln w="19050">
             <a:solidFill>
-              <a:srgbClr val="DC2626"/>
+              <a:srgbClr val="BE1E1E"/>
             </a:solidFill>
           </a:ln>
           <a:effectLst/>
@@ -2064,7 +2065,7 @@
             <a:r>
               <a:rPr sz="1300" b="1">
                 <a:solidFill>
-                  <a:srgbClr val="991B1B"/>
+                  <a:srgbClr val="7E1414"/>
                 </a:solidFill>
                 <a:latin typeface="Microsoft YaHei"/>
                 <a:ea typeface="Microsoft YaHei"/>
@@ -2151,11 +2152,11 @@
             </a:avLst>
           </a:prstGeom>
           <a:solidFill>
-            <a:srgbClr val="DBEAFE"/>
+            <a:srgbClr val="D4C2E5"/>
           </a:solidFill>
           <a:ln w="19050">
             <a:solidFill>
-              <a:srgbClr val="1D4ED8"/>
+              <a:srgbClr val="46196B"/>
             </a:solidFill>
           </a:ln>
           <a:effectLst/>
@@ -2182,7 +2183,7 @@
             <a:r>
               <a:rPr sz="1300" b="1">
                 <a:solidFill>
-                  <a:srgbClr val="1E3A8A"/>
+                  <a:srgbClr val="2C0E48"/>
                 </a:solidFill>
                 <a:latin typeface="Microsoft YaHei"/>
                 <a:ea typeface="Microsoft YaHei"/>
@@ -2210,11 +2211,11 @@
             </a:avLst>
           </a:prstGeom>
           <a:solidFill>
-            <a:srgbClr val="DBEAFE"/>
+            <a:srgbClr val="D4C2E5"/>
           </a:solidFill>
           <a:ln w="19050">
             <a:solidFill>
-              <a:srgbClr val="1D4ED8"/>
+              <a:srgbClr val="46196B"/>
             </a:solidFill>
           </a:ln>
           <a:effectLst/>
@@ -2241,7 +2242,7 @@
             <a:r>
               <a:rPr sz="1300" b="1">
                 <a:solidFill>
-                  <a:srgbClr val="1E3A8A"/>
+                  <a:srgbClr val="2C0E48"/>
                 </a:solidFill>
                 <a:latin typeface="Microsoft YaHei"/>
                 <a:ea typeface="Microsoft YaHei"/>
@@ -2269,11 +2270,11 @@
             </a:avLst>
           </a:prstGeom>
           <a:solidFill>
-            <a:srgbClr val="CCFBF1"/>
+            <a:srgbClr val="9FE2D4"/>
           </a:solidFill>
           <a:ln w="19050">
             <a:solidFill>
-              <a:srgbClr val="0D9488"/>
+              <a:srgbClr val="0B7D72"/>
             </a:solidFill>
           </a:ln>
           <a:effectLst/>
@@ -2300,7 +2301,7 @@
             <a:r>
               <a:rPr sz="1300" b="1">
                 <a:solidFill>
-                  <a:srgbClr val="115E59"/>
+                  <a:srgbClr val="084A43"/>
                 </a:solidFill>
                 <a:latin typeface="Microsoft YaHei"/>
                 <a:ea typeface="Microsoft YaHei"/>
@@ -2328,11 +2329,11 @@
             </a:avLst>
           </a:prstGeom>
           <a:solidFill>
-            <a:srgbClr val="CCFBF1"/>
+            <a:srgbClr val="9FE2D4"/>
           </a:solidFill>
           <a:ln w="19050">
             <a:solidFill>
-              <a:srgbClr val="0D9488"/>
+              <a:srgbClr val="0B7D72"/>
             </a:solidFill>
           </a:ln>
           <a:effectLst/>
@@ -2359,7 +2360,7 @@
             <a:r>
               <a:rPr sz="1300" b="1">
                 <a:solidFill>
-                  <a:srgbClr val="115E59"/>
+                  <a:srgbClr val="084A43"/>
                 </a:solidFill>
                 <a:latin typeface="Microsoft YaHei"/>
                 <a:ea typeface="Microsoft YaHei"/>
@@ -2387,11 +2388,11 @@
             </a:avLst>
           </a:prstGeom>
           <a:solidFill>
-            <a:srgbClr val="FEE2E2"/>
+            <a:srgbClr val="E6ADAD"/>
           </a:solidFill>
           <a:ln w="19050">
             <a:solidFill>
-              <a:srgbClr val="DC2626"/>
+              <a:srgbClr val="BE1E1E"/>
             </a:solidFill>
           </a:ln>
           <a:effectLst/>
@@ -2418,7 +2419,7 @@
             <a:r>
               <a:rPr sz="1300" b="1">
                 <a:solidFill>
-                  <a:srgbClr val="991B1B"/>
+                  <a:srgbClr val="7E1414"/>
                 </a:solidFill>
                 <a:latin typeface="Microsoft YaHei"/>
                 <a:ea typeface="Microsoft YaHei"/>
@@ -2446,11 +2447,11 @@
             </a:avLst>
           </a:prstGeom>
           <a:solidFill>
-            <a:srgbClr val="FEE2E2"/>
+            <a:srgbClr val="E6ADAD"/>
           </a:solidFill>
           <a:ln w="19050">
             <a:solidFill>
-              <a:srgbClr val="DC2626"/>
+              <a:srgbClr val="BE1E1E"/>
             </a:solidFill>
           </a:ln>
           <a:effectLst/>
@@ -2477,7 +2478,7 @@
             <a:r>
               <a:rPr sz="1300" b="1">
                 <a:solidFill>
-                  <a:srgbClr val="991B1B"/>
+                  <a:srgbClr val="7E1414"/>
                 </a:solidFill>
                 <a:latin typeface="Microsoft YaHei"/>
                 <a:ea typeface="Microsoft YaHei"/>
@@ -2578,7 +2579,7 @@
           </a:prstGeom>
           <a:ln w="19050">
             <a:solidFill>
-              <a:srgbClr val="DC2626"/>
+              <a:srgbClr val="BE1E1E"/>
             </a:solidFill>
             <a:tailEnd type="triangle" w="med" len="med"/>
           </a:ln>
@@ -2615,7 +2616,7 @@
           </a:prstGeom>
           <a:ln w="19050">
             <a:solidFill>
-              <a:srgbClr val="DC2626"/>
+              <a:srgbClr val="BE1E1E"/>
             </a:solidFill>
             <a:tailEnd type="triangle" w="med" len="med"/>
           </a:ln>
@@ -2921,7 +2922,7 @@
             <a:r>
               <a:rPr sz="1150" b="1">
                 <a:solidFill>
-                  <a:srgbClr val="991B1B"/>
+                  <a:srgbClr val="7E1414"/>
                 </a:solidFill>
                 <a:latin typeface="Microsoft YaHei"/>
                 <a:ea typeface="Microsoft YaHei"/>
@@ -2958,7 +2959,7 @@
             <a:r>
               <a:rPr sz="1150" b="1">
                 <a:solidFill>
-                  <a:srgbClr val="115E59"/>
+                  <a:srgbClr val="084A43"/>
                 </a:solidFill>
                 <a:latin typeface="Microsoft YaHei"/>
                 <a:ea typeface="Microsoft YaHei"/>
@@ -2995,7 +2996,7 @@
             <a:r>
               <a:rPr sz="950" b="0">
                 <a:solidFill>
-                  <a:srgbClr val="991B1B"/>
+                  <a:srgbClr val="7E1414"/>
                 </a:solidFill>
                 <a:latin typeface="Microsoft YaHei"/>
                 <a:ea typeface="Microsoft YaHei"/>
@@ -3032,7 +3033,7 @@
             <a:r>
               <a:rPr sz="950" b="0">
                 <a:solidFill>
-                  <a:srgbClr val="115E59"/>
+                  <a:srgbClr val="084A43"/>
                 </a:solidFill>
                 <a:latin typeface="Microsoft YaHei"/>
                 <a:ea typeface="Microsoft YaHei"/>
@@ -3066,7 +3067,7 @@
           <a:lstStyle/>
           <a:p>
             <a:pPr algn="r"/>
-            <a:fld id="{BD822B1F-EF48-4D65-9049-7C7FBA70B969}" type="slidenum">
+            <a:fld id="{44A89C8D-5661-48E9-8221-A412247FAC95}" type="slidenum">
               <a:rPr lang="en-US" sz="1000">
                 <a:solidFill>
                   <a:srgbClr val="9AA3B0"/>
@@ -3208,7 +3209,7 @@
             <a:r>
               <a:rPr sz="1200" b="1">
                 <a:solidFill>
-                  <a:srgbClr val="1D4ED8"/>
+                  <a:srgbClr val="46196B"/>
                 </a:solidFill>
                 <a:latin typeface="Microsoft YaHei"/>
                 <a:ea typeface="Microsoft YaHei"/>
@@ -3415,7 +3416,7 @@
           <a:lstStyle/>
           <a:p>
             <a:pPr algn="r"/>
-            <a:fld id="{67541B69-78B2-40D5-825F-742B1E0DF2F2}" type="slidenum">
+            <a:fld id="{565ABF09-248F-489A-A768-45CC35F85661}" type="slidenum">
               <a:rPr lang="en-US" sz="1000">
                 <a:solidFill>
                   <a:srgbClr val="9AA3B0"/>
@@ -3557,7 +3558,7 @@
             <a:r>
               <a:rPr sz="1200" b="1">
                 <a:solidFill>
-                  <a:srgbClr val="1D4ED8"/>
+                  <a:srgbClr val="46196B"/>
                 </a:solidFill>
                 <a:latin typeface="Microsoft YaHei"/>
                 <a:ea typeface="Microsoft YaHei"/>
@@ -3633,7 +3634,7 @@
                       </a:solidFill>
                     </a:lnB>
                     <a:solidFill>
-                      <a:srgbClr val="1D4ED8"/>
+                      <a:srgbClr val="46196B"/>
                     </a:solidFill>
                   </a:tcPr>
                 </a:tc>
@@ -3678,7 +3679,7 @@
                       </a:solidFill>
                     </a:lnB>
                     <a:solidFill>
-                      <a:srgbClr val="1D4ED8"/>
+                      <a:srgbClr val="46196B"/>
                     </a:solidFill>
                   </a:tcPr>
                 </a:tc>
@@ -3723,7 +3724,7 @@
                       </a:solidFill>
                     </a:lnB>
                     <a:solidFill>
-                      <a:srgbClr val="1D4ED8"/>
+                      <a:srgbClr val="46196B"/>
                     </a:solidFill>
                   </a:tcPr>
                 </a:tc>
@@ -4303,7 +4304,7 @@
           <a:lstStyle/>
           <a:p>
             <a:pPr algn="r"/>
-            <a:fld id="{0F1FF2F7-0690-46D7-A380-6D4BF8DC4B85}" type="slidenum">
+            <a:fld id="{F7066D71-872D-4D5D-B69E-02D13E244D10}" type="slidenum">
               <a:rPr lang="en-US" sz="1000">
                 <a:solidFill>
                   <a:srgbClr val="9AA3B0"/>
@@ -4445,7 +4446,7 @@
             <a:r>
               <a:rPr sz="1200" b="1">
                 <a:solidFill>
-                  <a:srgbClr val="1D4ED8"/>
+                  <a:srgbClr val="46196B"/>
                 </a:solidFill>
                 <a:latin typeface="Microsoft YaHei"/>
                 <a:ea typeface="Microsoft YaHei"/>
@@ -4631,7 +4632,7 @@
           <a:lstStyle/>
           <a:p>
             <a:pPr algn="r"/>
-            <a:fld id="{3565EDBB-850B-46E4-964E-0F51F58FF39A}" type="slidenum">
+            <a:fld id="{9FC0710A-97AC-492F-9E12-D3078F6E2200}" type="slidenum">
               <a:rPr lang="en-US" sz="1000">
                 <a:solidFill>
                   <a:srgbClr val="9AA3B0"/>
@@ -4773,7 +4774,7 @@
             <a:r>
               <a:rPr sz="1200" b="1">
                 <a:solidFill>
-                  <a:srgbClr val="1D4ED8"/>
+                  <a:srgbClr val="46196B"/>
                 </a:solidFill>
                 <a:latin typeface="Microsoft YaHei"/>
                 <a:ea typeface="Microsoft YaHei"/>
@@ -5000,7 +5001,7 @@
           <a:lstStyle/>
           <a:p>
             <a:pPr algn="r"/>
-            <a:fld id="{148FBE15-6AC0-4F62-AF01-8DE4D8B16245}" type="slidenum">
+            <a:fld id="{ED8B721C-DA96-46B3-B83C-F791C748C87A}" type="slidenum">
               <a:rPr lang="en-US" sz="1000">
                 <a:solidFill>
                   <a:srgbClr val="9AA3B0"/>
@@ -5097,7 +5098,7 @@
             <a:avLst/>
           </a:prstGeom>
           <a:solidFill>
-            <a:srgbClr val="1D4ED8"/>
+            <a:srgbClr val="46196B"/>
           </a:solidFill>
           <a:ln>
             <a:noFill/>
@@ -5305,7 +5306,7 @@
             <a:avLst/>
           </a:prstGeom>
           <a:solidFill>
-            <a:srgbClr val="EA580C"/>
+            <a:srgbClr val="D14E0A"/>
           </a:solidFill>
           <a:ln>
             <a:noFill/>
@@ -5349,7 +5350,7 @@
             <a:avLst/>
           </a:prstGeom>
           <a:solidFill>
-            <a:srgbClr val="EA580C"/>
+            <a:srgbClr val="D14E0A"/>
           </a:solidFill>
           <a:ln>
             <a:noFill/>
@@ -5434,7 +5435,7 @@
             <a:avLst/>
           </a:prstGeom>
           <a:solidFill>
-            <a:srgbClr val="EA580C"/>
+            <a:srgbClr val="D14E0A"/>
           </a:solidFill>
           <a:ln>
             <a:noFill/>
@@ -5519,7 +5520,7 @@
             <a:avLst/>
           </a:prstGeom>
           <a:solidFill>
-            <a:srgbClr val="EA580C"/>
+            <a:srgbClr val="D14E0A"/>
           </a:solidFill>
           <a:ln>
             <a:noFill/>
@@ -5719,7 +5720,7 @@
             <a:r>
               <a:rPr sz="1200" b="1">
                 <a:solidFill>
-                  <a:srgbClr val="1D4ED8"/>
+                  <a:srgbClr val="46196B"/>
                 </a:solidFill>
                 <a:latin typeface="Microsoft YaHei"/>
                 <a:ea typeface="Microsoft YaHei"/>
@@ -5955,11 +5956,11 @@
             </a:avLst>
           </a:prstGeom>
           <a:solidFill>
-            <a:srgbClr val="DBEAFE"/>
+            <a:srgbClr val="D4C2E5"/>
           </a:solidFill>
           <a:ln w="19050">
             <a:solidFill>
-              <a:srgbClr val="1D4ED8"/>
+              <a:srgbClr val="46196B"/>
             </a:solidFill>
           </a:ln>
           <a:effectLst/>
@@ -5986,7 +5987,7 @@
             <a:r>
               <a:rPr sz="1200" b="1">
                 <a:solidFill>
-                  <a:srgbClr val="1E3A8A"/>
+                  <a:srgbClr val="2C0E48"/>
                 </a:solidFill>
                 <a:latin typeface="Microsoft YaHei"/>
                 <a:ea typeface="Microsoft YaHei"/>
@@ -6000,7 +6001,7 @@
             <a:r>
               <a:rPr sz="1200" b="1">
                 <a:solidFill>
-                  <a:srgbClr val="1E3A8A"/>
+                  <a:srgbClr val="2C0E48"/>
                 </a:solidFill>
                 <a:latin typeface="Microsoft YaHei"/>
                 <a:ea typeface="Microsoft YaHei"/>
@@ -6146,11 +6147,11 @@
             </a:avLst>
           </a:prstGeom>
           <a:solidFill>
-            <a:srgbClr val="CCFBF1"/>
+            <a:srgbClr val="9FE2D4"/>
           </a:solidFill>
           <a:ln w="19050">
             <a:solidFill>
-              <a:srgbClr val="0D9488"/>
+              <a:srgbClr val="0B7D72"/>
             </a:solidFill>
           </a:ln>
           <a:effectLst/>
@@ -6177,7 +6178,7 @@
             <a:r>
               <a:rPr sz="1200" b="1">
                 <a:solidFill>
-                  <a:srgbClr val="115E59"/>
+                  <a:srgbClr val="084A43"/>
                 </a:solidFill>
                 <a:latin typeface="Microsoft YaHei"/>
                 <a:ea typeface="Microsoft YaHei"/>
@@ -6205,11 +6206,11 @@
             </a:avLst>
           </a:prstGeom>
           <a:solidFill>
-            <a:srgbClr val="CCFBF1"/>
+            <a:srgbClr val="9FE2D4"/>
           </a:solidFill>
           <a:ln w="19050">
             <a:solidFill>
-              <a:srgbClr val="0D9488"/>
+              <a:srgbClr val="0B7D72"/>
             </a:solidFill>
           </a:ln>
           <a:effectLst/>
@@ -6236,7 +6237,7 @@
             <a:r>
               <a:rPr sz="1200" b="1">
                 <a:solidFill>
-                  <a:srgbClr val="115E59"/>
+                  <a:srgbClr val="084A43"/>
                 </a:solidFill>
                 <a:latin typeface="Microsoft YaHei"/>
                 <a:ea typeface="Microsoft YaHei"/>
@@ -6264,11 +6265,11 @@
             </a:avLst>
           </a:prstGeom>
           <a:solidFill>
-            <a:srgbClr val="CCFBF1"/>
+            <a:srgbClr val="9FE2D4"/>
           </a:solidFill>
           <a:ln w="19050">
             <a:solidFill>
-              <a:srgbClr val="0D9488"/>
+              <a:srgbClr val="0B7D72"/>
             </a:solidFill>
           </a:ln>
           <a:effectLst/>
@@ -6295,7 +6296,7 @@
             <a:r>
               <a:rPr sz="1200" b="1">
                 <a:solidFill>
-                  <a:srgbClr val="115E59"/>
+                  <a:srgbClr val="084A43"/>
                 </a:solidFill>
                 <a:latin typeface="Microsoft YaHei"/>
                 <a:ea typeface="Microsoft YaHei"/>
@@ -6502,7 +6503,7 @@
             <a:r>
               <a:rPr sz="1400" b="1">
                 <a:solidFill>
-                  <a:srgbClr val="1E3A8A"/>
+                  <a:srgbClr val="2C0E48"/>
                 </a:solidFill>
                 <a:latin typeface="Microsoft YaHei"/>
                 <a:ea typeface="Microsoft YaHei"/>
@@ -6539,7 +6540,7 @@
             <a:r>
               <a:rPr sz="1400" b="1">
                 <a:solidFill>
-                  <a:srgbClr val="115E59"/>
+                  <a:srgbClr val="084A43"/>
                 </a:solidFill>
                 <a:latin typeface="Microsoft YaHei"/>
                 <a:ea typeface="Microsoft YaHei"/>
@@ -6721,7 +6722,7 @@
           <a:lstStyle/>
           <a:p>
             <a:pPr algn="r"/>
-            <a:fld id="{111319D4-A014-4B16-A5D4-89B2D27E35EF}" type="slidenum">
+            <a:fld id="{68A6822C-A5D4-4A12-AC37-3288FE17237F}" type="slidenum">
               <a:rPr lang="en-US" sz="1000">
                 <a:solidFill>
                   <a:srgbClr val="9AA3B0"/>
@@ -6863,7 +6864,7 @@
             <a:r>
               <a:rPr sz="1200" b="1">
                 <a:solidFill>
-                  <a:srgbClr val="1D4ED8"/>
+                  <a:srgbClr val="46196B"/>
                 </a:solidFill>
                 <a:latin typeface="Microsoft YaHei"/>
                 <a:ea typeface="Microsoft YaHei"/>
@@ -7070,7 +7071,7 @@
           <a:lstStyle/>
           <a:p>
             <a:pPr algn="r"/>
-            <a:fld id="{F05F5638-7A76-4F8D-9513-CAF4681F7ACF}" type="slidenum">
+            <a:fld id="{C9DD2837-2E52-440B-901A-2FBD65BB6A5E}" type="slidenum">
               <a:rPr lang="en-US" sz="1000">
                 <a:solidFill>
                   <a:srgbClr val="9AA3B0"/>
@@ -7205,7 +7206,7 @@
             <a:avLst/>
           </a:prstGeom>
           <a:solidFill>
-            <a:srgbClr val="1D4ED8"/>
+            <a:srgbClr val="46196B"/>
           </a:solidFill>
           <a:ln>
             <a:noFill/>
@@ -7342,7 +7343,7 @@
             <a:avLst/>
           </a:prstGeom>
           <a:solidFill>
-            <a:srgbClr val="1D4ED8"/>
+            <a:srgbClr val="46196B"/>
           </a:solidFill>
           <a:ln>
             <a:noFill/>
@@ -7479,7 +7480,7 @@
             <a:avLst/>
           </a:prstGeom>
           <a:solidFill>
-            <a:srgbClr val="1D4ED8"/>
+            <a:srgbClr val="46196B"/>
           </a:solidFill>
           <a:ln>
             <a:noFill/>
@@ -7616,7 +7617,7 @@
             <a:avLst/>
           </a:prstGeom>
           <a:solidFill>
-            <a:srgbClr val="1D4ED8"/>
+            <a:srgbClr val="46196B"/>
           </a:solidFill>
           <a:ln>
             <a:noFill/>
@@ -7753,7 +7754,7 @@
             <a:avLst/>
           </a:prstGeom>
           <a:solidFill>
-            <a:srgbClr val="1D4ED8"/>
+            <a:srgbClr val="46196B"/>
           </a:solidFill>
           <a:ln>
             <a:noFill/>
@@ -7985,7 +7986,7 @@
           <a:lstStyle/>
           <a:p>
             <a:pPr algn="r"/>
-            <a:fld id="{6ACA0FB2-2845-4399-BABE-DB1C926ED1B3}" type="slidenum">
+            <a:fld id="{3FD33110-F40A-4459-BB9B-845566F3AD4D}" type="slidenum">
               <a:rPr lang="en-US" sz="1000">
                 <a:solidFill>
                   <a:srgbClr val="9AA3B0"/>
@@ -8127,7 +8128,7 @@
             <a:r>
               <a:rPr sz="1200" b="1">
                 <a:solidFill>
-                  <a:srgbClr val="1D4ED8"/>
+                  <a:srgbClr val="46196B"/>
                 </a:solidFill>
                 <a:latin typeface="Microsoft YaHei"/>
                 <a:ea typeface="Microsoft YaHei"/>
@@ -8271,7 +8272,7 @@
           <a:lstStyle/>
           <a:p>
             <a:pPr algn="r"/>
-            <a:fld id="{EBB46898-A383-45D0-A462-D94FC6974E7A}" type="slidenum">
+            <a:fld id="{79E62872-3E29-4E47-8898-97597EB56FF1}" type="slidenum">
               <a:rPr lang="en-US" sz="1000">
                 <a:solidFill>
                   <a:srgbClr val="9AA3B0"/>
@@ -8368,7 +8369,7 @@
             <a:avLst/>
           </a:prstGeom>
           <a:solidFill>
-            <a:srgbClr val="1D4ED8"/>
+            <a:srgbClr val="46196B"/>
           </a:solidFill>
           <a:ln>
             <a:noFill/>
@@ -8576,7 +8577,7 @@
             <a:avLst/>
           </a:prstGeom>
           <a:solidFill>
-            <a:srgbClr val="EA580C"/>
+            <a:srgbClr val="D14E0A"/>
           </a:solidFill>
           <a:ln>
             <a:noFill/>
@@ -8620,7 +8621,7 @@
             <a:avLst/>
           </a:prstGeom>
           <a:solidFill>
-            <a:srgbClr val="EA580C"/>
+            <a:srgbClr val="D14E0A"/>
           </a:solidFill>
           <a:ln>
             <a:noFill/>
@@ -8705,7 +8706,7 @@
             <a:avLst/>
           </a:prstGeom>
           <a:solidFill>
-            <a:srgbClr val="EA580C"/>
+            <a:srgbClr val="D14E0A"/>
           </a:solidFill>
           <a:ln>
             <a:noFill/>
@@ -8790,7 +8791,7 @@
             <a:avLst/>
           </a:prstGeom>
           <a:solidFill>
-            <a:srgbClr val="EA580C"/>
+            <a:srgbClr val="D14E0A"/>
           </a:solidFill>
           <a:ln>
             <a:noFill/>
@@ -8875,7 +8876,7 @@
             <a:avLst/>
           </a:prstGeom>
           <a:solidFill>
-            <a:srgbClr val="EA580C"/>
+            <a:srgbClr val="D14E0A"/>
           </a:solidFill>
           <a:ln>
             <a:noFill/>
@@ -8960,7 +8961,7 @@
             <a:avLst/>
           </a:prstGeom>
           <a:solidFill>
-            <a:srgbClr val="EA580C"/>
+            <a:srgbClr val="D14E0A"/>
           </a:solidFill>
           <a:ln>
             <a:noFill/>
@@ -9045,7 +9046,7 @@
             <a:avLst/>
           </a:prstGeom>
           <a:solidFill>
-            <a:srgbClr val="EA580C"/>
+            <a:srgbClr val="D14E0A"/>
           </a:solidFill>
           <a:ln>
             <a:noFill/>
@@ -9130,7 +9131,7 @@
             <a:avLst/>
           </a:prstGeom>
           <a:solidFill>
-            <a:srgbClr val="EA580C"/>
+            <a:srgbClr val="D14E0A"/>
           </a:solidFill>
           <a:ln>
             <a:noFill/>
@@ -9330,7 +9331,7 @@
             <a:r>
               <a:rPr sz="1200" b="1">
                 <a:solidFill>
-                  <a:srgbClr val="1D4ED8"/>
+                  <a:srgbClr val="46196B"/>
                 </a:solidFill>
                 <a:latin typeface="Microsoft YaHei"/>
                 <a:ea typeface="Microsoft YaHei"/>
@@ -9474,7 +9475,7 @@
           <a:lstStyle/>
           <a:p>
             <a:pPr algn="r"/>
-            <a:fld id="{8E00E50A-D1FA-4270-A379-E752B4FDBAEA}" type="slidenum">
+            <a:fld id="{B826F250-3B01-4D25-B209-3CF86E8B3AEB}" type="slidenum">
               <a:rPr lang="en-US" sz="1000">
                 <a:solidFill>
                   <a:srgbClr val="9AA3B0"/>
@@ -9616,7 +9617,7 @@
             <a:r>
               <a:rPr sz="1200" b="1">
                 <a:solidFill>
-                  <a:srgbClr val="1D4ED8"/>
+                  <a:srgbClr val="46196B"/>
                 </a:solidFill>
                 <a:latin typeface="Microsoft YaHei"/>
                 <a:ea typeface="Microsoft YaHei"/>
@@ -9760,7 +9761,7 @@
           <a:lstStyle/>
           <a:p>
             <a:pPr algn="r"/>
-            <a:fld id="{F0A5BEF0-698C-48E8-83B3-8DFE9E5B7595}" type="slidenum">
+            <a:fld id="{D9CDA061-8AF7-463F-AD34-D08EE9EBF519}" type="slidenum">
               <a:rPr lang="en-US" sz="1000">
                 <a:solidFill>
                   <a:srgbClr val="9AA3B0"/>
@@ -9902,7 +9903,7 @@
             <a:r>
               <a:rPr sz="1200" b="1">
                 <a:solidFill>
-                  <a:srgbClr val="1D4ED8"/>
+                  <a:srgbClr val="46196B"/>
                 </a:solidFill>
                 <a:latin typeface="Microsoft YaHei"/>
                 <a:ea typeface="Microsoft YaHei"/>
@@ -10108,7 +10109,7 @@
           <a:lstStyle/>
           <a:p>
             <a:pPr algn="r"/>
-            <a:fld id="{04F41E0A-25D7-49C6-AA9E-5711A05BE535}" type="slidenum">
+            <a:fld id="{F5171AC3-DC9B-455C-9225-35D960FF9EE8}" type="slidenum">
               <a:rPr lang="en-US" sz="1000">
                 <a:solidFill>
                   <a:srgbClr val="9AA3B0"/>
@@ -10250,7 +10251,7 @@
             <a:r>
               <a:rPr sz="1200" b="1">
                 <a:solidFill>
-                  <a:srgbClr val="1D4ED8"/>
+                  <a:srgbClr val="46196B"/>
                 </a:solidFill>
                 <a:latin typeface="Microsoft YaHei"/>
                 <a:ea typeface="Microsoft YaHei"/>
@@ -10326,7 +10327,7 @@
                       </a:solidFill>
                     </a:lnB>
                     <a:solidFill>
-                      <a:srgbClr val="1D4ED8"/>
+                      <a:srgbClr val="46196B"/>
                     </a:solidFill>
                   </a:tcPr>
                 </a:tc>
@@ -10371,7 +10372,7 @@
                       </a:solidFill>
                     </a:lnB>
                     <a:solidFill>
-                      <a:srgbClr val="1D4ED8"/>
+                      <a:srgbClr val="46196B"/>
                     </a:solidFill>
                   </a:tcPr>
                 </a:tc>
@@ -10416,7 +10417,7 @@
                       </a:solidFill>
                     </a:lnB>
                     <a:solidFill>
-                      <a:srgbClr val="1D4ED8"/>
+                      <a:srgbClr val="46196B"/>
                     </a:solidFill>
                   </a:tcPr>
                 </a:tc>
@@ -10996,7 +10997,7 @@
           <a:lstStyle/>
           <a:p>
             <a:pPr algn="r"/>
-            <a:fld id="{B6B3AC91-5145-4ABB-87E2-AF8247D5101D}" type="slidenum">
+            <a:fld id="{11186BA3-23DE-4388-B82F-4C4EFF0BA1C9}" type="slidenum">
               <a:rPr lang="en-US" sz="1000">
                 <a:solidFill>
                   <a:srgbClr val="9AA3B0"/>
@@ -11138,7 +11139,7 @@
             <a:r>
               <a:rPr sz="1200" b="1">
                 <a:solidFill>
-                  <a:srgbClr val="1D4ED8"/>
+                  <a:srgbClr val="46196B"/>
                 </a:solidFill>
                 <a:latin typeface="Microsoft YaHei"/>
                 <a:ea typeface="Microsoft YaHei"/>
@@ -11213,7 +11214,7 @@
                       </a:solidFill>
                     </a:lnB>
                     <a:solidFill>
-                      <a:srgbClr val="1D4ED8"/>
+                      <a:srgbClr val="46196B"/>
                     </a:solidFill>
                   </a:tcPr>
                 </a:tc>
@@ -11258,7 +11259,7 @@
                       </a:solidFill>
                     </a:lnB>
                     <a:solidFill>
-                      <a:srgbClr val="1D4ED8"/>
+                      <a:srgbClr val="46196B"/>
                     </a:solidFill>
                   </a:tcPr>
                 </a:tc>
@@ -11842,7 +11843,7 @@
           <a:lstStyle/>
           <a:p>
             <a:pPr algn="r"/>
-            <a:fld id="{B14515C1-5FBD-476F-919B-B911DD859E43}" type="slidenum">
+            <a:fld id="{89C5AE57-49C7-4349-A1E1-0A5FC8CAD4CD}" type="slidenum">
               <a:rPr lang="en-US" sz="1000">
                 <a:solidFill>
                   <a:srgbClr val="9AA3B0"/>
@@ -11984,7 +11985,7 @@
             <a:r>
               <a:rPr sz="1200" b="1">
                 <a:solidFill>
-                  <a:srgbClr val="1D4ED8"/>
+                  <a:srgbClr val="46196B"/>
                 </a:solidFill>
                 <a:latin typeface="Microsoft YaHei"/>
                 <a:ea typeface="Microsoft YaHei"/>
@@ -12167,7 +12168,7 @@
           <a:lstStyle/>
           <a:p>
             <a:pPr algn="r"/>
-            <a:fld id="{0EA850DC-56B2-4AF1-8F51-DAC93BF57DFB}" type="slidenum">
+            <a:fld id="{F5ABEDF7-AA18-4B34-BF4E-0E7F9C2A27AE}" type="slidenum">
               <a:rPr lang="en-US" sz="1000">
                 <a:solidFill>
                   <a:srgbClr val="9AA3B0"/>
@@ -12309,7 +12310,7 @@
             <a:r>
               <a:rPr sz="1200" b="1">
                 <a:solidFill>
-                  <a:srgbClr val="1D4ED8"/>
+                  <a:srgbClr val="46196B"/>
                 </a:solidFill>
                 <a:latin typeface="Microsoft YaHei"/>
                 <a:ea typeface="Microsoft YaHei"/>
@@ -12516,7 +12517,7 @@
           <a:lstStyle/>
           <a:p>
             <a:pPr algn="r"/>
-            <a:fld id="{33D45A6D-6F2A-4824-AFC3-170715536317}" type="slidenum">
+            <a:fld id="{DAEE518D-4988-4FA4-865C-F0E7E2DF9397}" type="slidenum">
               <a:rPr lang="en-US" sz="1000">
                 <a:solidFill>
                   <a:srgbClr val="9AA3B0"/>
@@ -12613,7 +12614,7 @@
             <a:avLst/>
           </a:prstGeom>
           <a:solidFill>
-            <a:srgbClr val="1D4ED8"/>
+            <a:srgbClr val="46196B"/>
           </a:solidFill>
           <a:ln>
             <a:noFill/>
@@ -12821,7 +12822,7 @@
             <a:avLst/>
           </a:prstGeom>
           <a:solidFill>
-            <a:srgbClr val="EA580C"/>
+            <a:srgbClr val="D14E0A"/>
           </a:solidFill>
           <a:ln>
             <a:noFill/>
@@ -12865,7 +12866,7 @@
             <a:avLst/>
           </a:prstGeom>
           <a:solidFill>
-            <a:srgbClr val="EA580C"/>
+            <a:srgbClr val="D14E0A"/>
           </a:solidFill>
           <a:ln>
             <a:noFill/>
@@ -12950,7 +12951,7 @@
             <a:avLst/>
           </a:prstGeom>
           <a:solidFill>
-            <a:srgbClr val="EA580C"/>
+            <a:srgbClr val="D14E0A"/>
           </a:solidFill>
           <a:ln>
             <a:noFill/>
@@ -13105,7 +13106,7 @@
             <a:avLst/>
           </a:prstGeom>
           <a:solidFill>
-            <a:srgbClr val="1D4ED8"/>
+            <a:srgbClr val="46196B"/>
           </a:solidFill>
           <a:ln>
             <a:noFill/>
@@ -13313,7 +13314,7 @@
             <a:avLst/>
           </a:prstGeom>
           <a:solidFill>
-            <a:srgbClr val="EA580C"/>
+            <a:srgbClr val="D14E0A"/>
           </a:solidFill>
           <a:ln>
             <a:noFill/>
@@ -13357,7 +13358,7 @@
             <a:avLst/>
           </a:prstGeom>
           <a:solidFill>
-            <a:srgbClr val="EA580C"/>
+            <a:srgbClr val="D14E0A"/>
           </a:solidFill>
           <a:ln>
             <a:noFill/>
@@ -13442,7 +13443,7 @@
             <a:avLst/>
           </a:prstGeom>
           <a:solidFill>
-            <a:srgbClr val="EA580C"/>
+            <a:srgbClr val="D14E0A"/>
           </a:solidFill>
           <a:ln>
             <a:noFill/>
@@ -13527,7 +13528,7 @@
             <a:avLst/>
           </a:prstGeom>
           <a:solidFill>
-            <a:srgbClr val="EA580C"/>
+            <a:srgbClr val="D14E0A"/>
           </a:solidFill>
           <a:ln>
             <a:noFill/>
@@ -13612,7 +13613,7 @@
             <a:avLst/>
           </a:prstGeom>
           <a:solidFill>
-            <a:srgbClr val="EA580C"/>
+            <a:srgbClr val="D14E0A"/>
           </a:solidFill>
           <a:ln>
             <a:noFill/>
@@ -13697,7 +13698,7 @@
             <a:avLst/>
           </a:prstGeom>
           <a:solidFill>
-            <a:srgbClr val="EA580C"/>
+            <a:srgbClr val="D14E0A"/>
           </a:solidFill>
           <a:ln>
             <a:noFill/>
@@ -13897,7 +13898,7 @@
             <a:r>
               <a:rPr sz="1200" b="1">
                 <a:solidFill>
-                  <a:srgbClr val="1D4ED8"/>
+                  <a:srgbClr val="46196B"/>
                 </a:solidFill>
                 <a:latin typeface="Microsoft YaHei"/>
                 <a:ea typeface="Microsoft YaHei"/>
@@ -14074,11 +14075,11 @@
             </a:avLst>
           </a:prstGeom>
           <a:solidFill>
-            <a:srgbClr val="DBEAFE"/>
+            <a:srgbClr val="D4C2E5"/>
           </a:solidFill>
           <a:ln w="19050">
             <a:solidFill>
-              <a:srgbClr val="1D4ED8"/>
+              <a:srgbClr val="46196B"/>
             </a:solidFill>
           </a:ln>
           <a:effectLst/>
@@ -14105,7 +14106,7 @@
             <a:r>
               <a:rPr sz="1200" b="1">
                 <a:solidFill>
-                  <a:srgbClr val="1E3A8A"/>
+                  <a:srgbClr val="2C0E48"/>
                 </a:solidFill>
                 <a:latin typeface="Microsoft YaHei"/>
                 <a:ea typeface="Microsoft YaHei"/>
@@ -14119,7 +14120,7 @@
             <a:r>
               <a:rPr sz="1200" b="1">
                 <a:solidFill>
-                  <a:srgbClr val="1E3A8A"/>
+                  <a:srgbClr val="2C0E48"/>
                 </a:solidFill>
                 <a:latin typeface="Microsoft YaHei"/>
                 <a:ea typeface="Microsoft YaHei"/>
@@ -14147,11 +14148,11 @@
             </a:avLst>
           </a:prstGeom>
           <a:solidFill>
-            <a:srgbClr val="CCFBF1"/>
+            <a:srgbClr val="9FE2D4"/>
           </a:solidFill>
           <a:ln w="19050">
             <a:solidFill>
-              <a:srgbClr val="0D9488"/>
+              <a:srgbClr val="0B7D72"/>
             </a:solidFill>
           </a:ln>
           <a:effectLst/>
@@ -14178,7 +14179,7 @@
             <a:r>
               <a:rPr sz="1200" b="1">
                 <a:solidFill>
-                  <a:srgbClr val="115E59"/>
+                  <a:srgbClr val="084A43"/>
                 </a:solidFill>
                 <a:latin typeface="Microsoft YaHei"/>
                 <a:ea typeface="Microsoft YaHei"/>
@@ -14206,11 +14207,11 @@
             </a:avLst>
           </a:prstGeom>
           <a:solidFill>
-            <a:srgbClr val="FEE2E2"/>
+            <a:srgbClr val="E6ADAD"/>
           </a:solidFill>
           <a:ln w="19050">
             <a:solidFill>
-              <a:srgbClr val="DC2626"/>
+              <a:srgbClr val="BE1E1E"/>
             </a:solidFill>
           </a:ln>
           <a:effectLst/>
@@ -14237,7 +14238,7 @@
             <a:r>
               <a:rPr sz="1200" b="1">
                 <a:solidFill>
-                  <a:srgbClr val="991B1B"/>
+                  <a:srgbClr val="7E1414"/>
                 </a:solidFill>
                 <a:latin typeface="Microsoft YaHei"/>
                 <a:ea typeface="Microsoft YaHei"/>
@@ -14251,7 +14252,7 @@
             <a:r>
               <a:rPr sz="1200" b="1">
                 <a:solidFill>
-                  <a:srgbClr val="991B1B"/>
+                  <a:srgbClr val="7E1414"/>
                 </a:solidFill>
                 <a:latin typeface="Microsoft YaHei"/>
                 <a:ea typeface="Microsoft YaHei"/>
@@ -14279,11 +14280,11 @@
             </a:avLst>
           </a:prstGeom>
           <a:solidFill>
-            <a:srgbClr val="FFEDD5"/>
+            <a:srgbClr val="F6CD9E"/>
           </a:solidFill>
           <a:ln w="19050">
             <a:solidFill>
-              <a:srgbClr val="EA580C"/>
+              <a:srgbClr val="D14E0A"/>
             </a:solidFill>
           </a:ln>
           <a:effectLst/>
@@ -14310,7 +14311,7 @@
             <a:r>
               <a:rPr sz="1200" b="1">
                 <a:solidFill>
-                  <a:srgbClr val="9A3412"/>
+                  <a:srgbClr val="7E2E07"/>
                 </a:solidFill>
                 <a:latin typeface="Microsoft YaHei"/>
                 <a:ea typeface="Microsoft YaHei"/>
@@ -14566,7 +14567,7 @@
           <a:lstStyle/>
           <a:p>
             <a:pPr algn="r"/>
-            <a:fld id="{B66ADE2F-85CA-4958-9D74-89FFC6F6A5B7}" type="slidenum">
+            <a:fld id="{5285E3E6-2A4D-47AD-BF5C-D7CEEB40A442}" type="slidenum">
               <a:rPr lang="en-US" sz="1000">
                 <a:solidFill>
                   <a:srgbClr val="9AA3B0"/>
@@ -14708,7 +14709,7 @@
             <a:r>
               <a:rPr sz="1200" b="1">
                 <a:solidFill>
-                  <a:srgbClr val="1D4ED8"/>
+                  <a:srgbClr val="46196B"/>
                 </a:solidFill>
                 <a:latin typeface="Microsoft YaHei"/>
                 <a:ea typeface="Microsoft YaHei"/>
@@ -14784,7 +14785,7 @@
                       </a:solidFill>
                     </a:lnB>
                     <a:solidFill>
-                      <a:srgbClr val="1D4ED8"/>
+                      <a:srgbClr val="46196B"/>
                     </a:solidFill>
                   </a:tcPr>
                 </a:tc>
@@ -14829,7 +14830,7 @@
                       </a:solidFill>
                     </a:lnB>
                     <a:solidFill>
-                      <a:srgbClr val="1D4ED8"/>
+                      <a:srgbClr val="46196B"/>
                     </a:solidFill>
                   </a:tcPr>
                 </a:tc>
@@ -14874,7 +14875,7 @@
                       </a:solidFill>
                     </a:lnB>
                     <a:solidFill>
-                      <a:srgbClr val="1D4ED8"/>
+                      <a:srgbClr val="46196B"/>
                     </a:solidFill>
                   </a:tcPr>
                 </a:tc>
@@ -15591,7 +15592,7 @@
           <a:lstStyle/>
           <a:p>
             <a:pPr algn="r"/>
-            <a:fld id="{E7FC3159-9582-4614-A066-46C9A1D67AA4}" type="slidenum">
+            <a:fld id="{654FE9FD-3CB6-4B02-A613-08379A0890F9}" type="slidenum">
               <a:rPr lang="en-US" sz="1000">
                 <a:solidFill>
                   <a:srgbClr val="9AA3B0"/>
@@ -15733,7 +15734,7 @@
             <a:r>
               <a:rPr sz="1200" b="1">
                 <a:solidFill>
-                  <a:srgbClr val="1D4ED8"/>
+                  <a:srgbClr val="46196B"/>
                 </a:solidFill>
                 <a:latin typeface="Microsoft YaHei"/>
                 <a:ea typeface="Microsoft YaHei"/>
@@ -15805,7 +15806,7 @@
             <a:avLst/>
           </a:prstGeom>
           <a:solidFill>
-            <a:srgbClr val="1D4ED8"/>
+            <a:srgbClr val="46196B"/>
           </a:solidFill>
           <a:ln>
             <a:noFill/>
@@ -15864,7 +15865,7 @@
             <a:r>
               <a:rPr sz="1500" b="1">
                 <a:solidFill>
-                  <a:srgbClr val="1D4ED8"/>
+                  <a:srgbClr val="46196B"/>
                 </a:solidFill>
                 <a:latin typeface="Microsoft YaHei"/>
                 <a:ea typeface="Microsoft YaHei"/>
@@ -16106,7 +16107,7 @@
             <a:avLst/>
           </a:prstGeom>
           <a:solidFill>
-            <a:srgbClr val="EA580C"/>
+            <a:srgbClr val="D14E0A"/>
           </a:solidFill>
           <a:ln>
             <a:noFill/>
@@ -16165,7 +16166,7 @@
             <a:r>
               <a:rPr sz="1500" b="1">
                 <a:solidFill>
-                  <a:srgbClr val="EA580C"/>
+                  <a:srgbClr val="D14E0A"/>
                 </a:solidFill>
                 <a:latin typeface="Microsoft YaHei"/>
                 <a:ea typeface="Microsoft YaHei"/>
@@ -16369,7 +16370,7 @@
           <a:lstStyle/>
           <a:p>
             <a:pPr algn="r"/>
-            <a:fld id="{6EBA6E46-ED12-46D4-B6A8-77153A5D5B2F}" type="slidenum">
+            <a:fld id="{19D6D63A-F81A-4294-8E30-6DDCA72C2DC3}" type="slidenum">
               <a:rPr lang="en-US" sz="1000">
                 <a:solidFill>
                   <a:srgbClr val="9AA3B0"/>
@@ -16390,6 +16391,310 @@
 </file>
 
 <file path=ppt/slides/slide33.xml><?xml version="1.0" encoding="utf-8"?>
+<p:sld xmlns:a="http://schemas.openxmlformats.org/drawingml/2006/main" xmlns:p="http://schemas.openxmlformats.org/presentationml/2006/main" xmlns:r="http://schemas.openxmlformats.org/officeDocument/2006/relationships">
+  <p:cSld>
+    <p:spTree>
+      <p:nvGrpSpPr>
+        <p:cNvPr id="1" name=""/>
+        <p:cNvGrpSpPr/>
+        <p:nvPr/>
+      </p:nvGrpSpPr>
+      <p:grpSpPr/>
+      <p:sp>
+        <p:nvSpPr>
+          <p:cNvPr id="2" name="TextBox 1"/>
+          <p:cNvSpPr txBox="1"/>
+          <p:nvPr/>
+        </p:nvSpPr>
+        <p:spPr>
+          <a:xfrm>
+            <a:off x="777240" y="384048"/>
+            <a:ext cx="8412480" cy="731520"/>
+          </a:xfrm>
+          <a:prstGeom prst="rect">
+            <a:avLst/>
+          </a:prstGeom>
+          <a:noFill/>
+        </p:spPr>
+        <p:txBody>
+          <a:bodyPr wrap="square" anchor="t" lIns="25400" rIns="25400" tIns="25400" bIns="25400">
+            <a:spAutoFit/>
+          </a:bodyPr>
+          <a:lstStyle/>
+          <a:p>
+            <a:pPr algn="l">
+              <a:spcAft>
+                <a:spcPts val="600"/>
+              </a:spcAft>
+            </a:pPr>
+            <a:r>
+              <a:rPr sz="2800" b="1">
+                <a:solidFill>
+                  <a:srgbClr val="1A1F2B"/>
+                </a:solidFill>
+                <a:latin typeface="Microsoft YaHei"/>
+                <a:ea typeface="Microsoft YaHei"/>
+                <a:cs typeface="Microsoft YaHei"/>
+              </a:rPr>
+              <a:t>参考文献 References</a:t>
+            </a:r>
+          </a:p>
+        </p:txBody>
+      </p:sp>
+      <p:sp>
+        <p:nvSpPr>
+          <p:cNvPr id="3" name="TextBox 2"/>
+          <p:cNvSpPr txBox="1"/>
+          <p:nvPr/>
+        </p:nvSpPr>
+        <p:spPr>
+          <a:xfrm>
+            <a:off x="795528" y="1078992"/>
+            <a:ext cx="8412480" cy="457200"/>
+          </a:xfrm>
+          <a:prstGeom prst="rect">
+            <a:avLst/>
+          </a:prstGeom>
+          <a:noFill/>
+        </p:spPr>
+        <p:txBody>
+          <a:bodyPr wrap="square" anchor="t" lIns="25400" rIns="25400" tIns="25400" bIns="25400">
+            <a:spAutoFit/>
+          </a:bodyPr>
+          <a:lstStyle/>
+          <a:p>
+            <a:pPr algn="l">
+              <a:spcAft>
+                <a:spcPts val="600"/>
+              </a:spcAft>
+            </a:pPr>
+            <a:r>
+              <a:rPr sz="1400" b="0">
+                <a:solidFill>
+                  <a:srgbClr val="3A4252"/>
+                </a:solidFill>
+                <a:latin typeface="Microsoft YaHei"/>
+                <a:ea typeface="Microsoft YaHei"/>
+                <a:cs typeface="Microsoft YaHei"/>
+              </a:rPr>
+              <a:t>本讲内容与图示来源（引用文献插图时图下另标“来源：…”）</a:t>
+            </a:r>
+          </a:p>
+        </p:txBody>
+      </p:sp>
+      <p:sp>
+        <p:nvSpPr>
+          <p:cNvPr id="4" name="TextBox 3"/>
+          <p:cNvSpPr txBox="1"/>
+          <p:nvPr/>
+        </p:nvSpPr>
+        <p:spPr>
+          <a:xfrm>
+            <a:off x="8549640" y="502920"/>
+            <a:ext cx="3063240" cy="365760"/>
+          </a:xfrm>
+          <a:prstGeom prst="rect">
+            <a:avLst/>
+          </a:prstGeom>
+          <a:noFill/>
+        </p:spPr>
+        <p:txBody>
+          <a:bodyPr wrap="square" anchor="t" lIns="25400" rIns="25400" tIns="25400" bIns="25400">
+            <a:spAutoFit/>
+          </a:bodyPr>
+          <a:lstStyle/>
+          <a:p>
+            <a:pPr algn="r">
+              <a:spcAft>
+                <a:spcPts val="600"/>
+              </a:spcAft>
+            </a:pPr>
+            <a:r>
+              <a:rPr sz="1200" b="1">
+                <a:solidFill>
+                  <a:srgbClr val="46196B"/>
+                </a:solidFill>
+                <a:latin typeface="Microsoft YaHei"/>
+                <a:ea typeface="Microsoft YaHei"/>
+                <a:cs typeface="Microsoft YaHei"/>
+              </a:rPr>
+              <a:t>第5章 · 工具流程与调试收束</a:t>
+            </a:r>
+          </a:p>
+        </p:txBody>
+      </p:sp>
+      <p:sp>
+        <p:nvSpPr>
+          <p:cNvPr id="5" name="TextBox 4"/>
+          <p:cNvSpPr txBox="1"/>
+          <p:nvPr/>
+        </p:nvSpPr>
+        <p:spPr>
+          <a:xfrm>
+            <a:off x="640080" y="1627632"/>
+            <a:ext cx="10972800" cy="4754880"/>
+          </a:xfrm>
+          <a:prstGeom prst="rect">
+            <a:avLst/>
+          </a:prstGeom>
+          <a:noFill/>
+        </p:spPr>
+        <p:txBody>
+          <a:bodyPr wrap="square" anchor="t" lIns="25400" rIns="25400" tIns="25400" bIns="25400">
+            <a:normAutofit/>
+          </a:bodyPr>
+          <a:lstStyle/>
+          <a:p>
+            <a:pPr algn="l">
+              <a:lnSpc>
+                <a:spcPct val="120000"/>
+              </a:lnSpc>
+              <a:spcAft>
+                <a:spcPts val="900"/>
+              </a:spcAft>
+            </a:pPr>
+            <a:r>
+              <a:rPr sz="1250" b="0">
+                <a:solidFill>
+                  <a:srgbClr val="1A1F2B"/>
+                </a:solidFill>
+                <a:latin typeface="Microsoft YaHei"/>
+                <a:ea typeface="Microsoft YaHei"/>
+                <a:cs typeface="Microsoft YaHei"/>
+              </a:rPr>
+              <a:t>[1]  Adam Teman. Digital VLSI Design (DVD), Lecture 6 — Import Design and Floorplan. Bar-Ilan University, Course 83-612. https://enicslabs.com/academic-courses/dvd-english/</a:t>
+            </a:r>
+          </a:p>
+          <a:p>
+            <a:pPr algn="l">
+              <a:lnSpc>
+                <a:spcPct val="120000"/>
+              </a:lnSpc>
+              <a:spcAft>
+                <a:spcPts val="900"/>
+              </a:spcAft>
+            </a:pPr>
+            <a:r>
+              <a:rPr sz="1250" b="0">
+                <a:solidFill>
+                  <a:srgbClr val="1A1F2B"/>
+                </a:solidFill>
+                <a:latin typeface="Microsoft YaHei"/>
+                <a:ea typeface="Microsoft YaHei"/>
+                <a:cs typeface="Microsoft YaHei"/>
+              </a:rPr>
+              <a:t>[2]  J. M. Rabaey, A. Chandrakasan, B. Nikolić. Digital Integrated Circuits: A Design Perspective. Prentice Hall.</a:t>
+            </a:r>
+          </a:p>
+          <a:p>
+            <a:pPr algn="l">
+              <a:lnSpc>
+                <a:spcPct val="120000"/>
+              </a:lnSpc>
+              <a:spcAft>
+                <a:spcPts val="900"/>
+              </a:spcAft>
+            </a:pPr>
+            <a:r>
+              <a:rPr sz="1250" b="0">
+                <a:solidFill>
+                  <a:srgbClr val="1A1F2B"/>
+                </a:solidFill>
+                <a:latin typeface="Microsoft YaHei"/>
+                <a:ea typeface="Microsoft YaHei"/>
+                <a:cs typeface="Microsoft YaHei"/>
+              </a:rPr>
+              <a:t>[3]  N. H. E. Weste, D. M. Harris. CMOS VLSI Design: A Circuits and Systems Perspective. Addison-Wesley.</a:t>
+            </a:r>
+          </a:p>
+          <a:p>
+            <a:pPr algn="l">
+              <a:lnSpc>
+                <a:spcPct val="120000"/>
+              </a:lnSpc>
+              <a:spcAft>
+                <a:spcPts val="900"/>
+              </a:spcAft>
+            </a:pPr>
+            <a:r>
+              <a:rPr sz="1250" b="0">
+                <a:solidFill>
+                  <a:srgbClr val="1A1F2B"/>
+                </a:solidFill>
+                <a:latin typeface="Microsoft YaHei"/>
+                <a:ea typeface="Microsoft YaHei"/>
+                <a:cs typeface="Microsoft YaHei"/>
+              </a:rPr>
+              <a:t>[4]  IDESA / EPFL — Digital IC design tutorials.</a:t>
+            </a:r>
+          </a:p>
+          <a:p>
+            <a:pPr algn="l">
+              <a:lnSpc>
+                <a:spcPct val="120000"/>
+              </a:lnSpc>
+              <a:spcAft>
+                <a:spcPts val="900"/>
+              </a:spcAft>
+            </a:pPr>
+            <a:r>
+              <a:rPr sz="1250" b="0">
+                <a:solidFill>
+                  <a:srgbClr val="1A1F2B"/>
+                </a:solidFill>
+                <a:latin typeface="Microsoft YaHei"/>
+                <a:ea typeface="Microsoft YaHei"/>
+                <a:cs typeface="Microsoft YaHei"/>
+              </a:rPr>
+              <a:t>[5]  Cadence Innovus User Guide; Synopsys IC Compiler II / Fusion Compiler User Guide（命令与流程参考）.</a:t>
+            </a:r>
+          </a:p>
+        </p:txBody>
+      </p:sp>
+      <p:sp>
+        <p:nvSpPr>
+          <p:cNvPr id="6" name="TextBox 5"/>
+          <p:cNvSpPr txBox="1"/>
+          <p:nvPr/>
+        </p:nvSpPr>
+        <p:spPr>
+          <a:xfrm>
+            <a:off x="9875520" y="6446520"/>
+            <a:ext cx="2011680" cy="365760"/>
+          </a:xfrm>
+          <a:prstGeom prst="rect">
+            <a:avLst/>
+          </a:prstGeom>
+          <a:noFill/>
+        </p:spPr>
+        <p:txBody>
+          <a:bodyPr wrap="none" lIns="0" rIns="0" tIns="0" bIns="0">
+            <a:spAutoFit/>
+          </a:bodyPr>
+          <a:lstStyle/>
+          <a:p>
+            <a:pPr algn="r"/>
+            <a:fld id="{BECAA061-F3CE-4A7F-9168-D8D5958EE520}" type="slidenum">
+              <a:rPr lang="en-US" sz="1000">
+                <a:solidFill>
+                  <a:srgbClr val="9AA3B0"/>
+                </a:solidFill>
+                <a:latin typeface="Microsoft YaHei"/>
+              </a:rPr>
+              <a:t>1</a:t>
+            </a:fld>
+          </a:p>
+        </p:txBody>
+      </p:sp>
+    </p:spTree>
+  </p:cSld>
+  <p:clrMapOvr>
+    <a:masterClrMapping/>
+  </p:clrMapOvr>
+</p:sld>
+</file>
+
+<file path=ppt/slides/slide34.xml><?xml version="1.0" encoding="utf-8"?>
 <p:sld xmlns:a="http://schemas.openxmlformats.org/drawingml/2006/main" xmlns:p="http://schemas.openxmlformats.org/presentationml/2006/main" xmlns:r="http://schemas.openxmlformats.org/officeDocument/2006/relationships">
   <p:cSld>
     <p:bg>
@@ -16466,7 +16771,7 @@
             <a:avLst/>
           </a:prstGeom>
           <a:solidFill>
-            <a:srgbClr val="1D4ED8"/>
+            <a:srgbClr val="46196B"/>
           </a:solidFill>
           <a:ln>
             <a:noFill/>
@@ -16592,7 +16897,7 @@
             <a:avLst/>
           </a:prstGeom>
           <a:solidFill>
-            <a:srgbClr val="EA580C"/>
+            <a:srgbClr val="D14E0A"/>
           </a:solidFill>
           <a:ln>
             <a:noFill/>
@@ -16833,7 +17138,7 @@
             <a:r>
               <a:rPr sz="1200" b="1">
                 <a:solidFill>
-                  <a:srgbClr val="1D4ED8"/>
+                  <a:srgbClr val="46196B"/>
                 </a:solidFill>
                 <a:latin typeface="Microsoft YaHei"/>
                 <a:ea typeface="Microsoft YaHei"/>
@@ -17016,7 +17321,7 @@
           <a:lstStyle/>
           <a:p>
             <a:pPr algn="r"/>
-            <a:fld id="{BF0BA4ED-7E09-450E-A607-78D533EDB2A3}" type="slidenum">
+            <a:fld id="{7B2F862D-C701-4A32-886D-91D45049BCE6}" type="slidenum">
               <a:rPr lang="en-US" sz="1000">
                 <a:solidFill>
                   <a:srgbClr val="9AA3B0"/>
@@ -17158,7 +17463,7 @@
             <a:r>
               <a:rPr sz="1200" b="1">
                 <a:solidFill>
-                  <a:srgbClr val="1D4ED8"/>
+                  <a:srgbClr val="46196B"/>
                 </a:solidFill>
                 <a:latin typeface="Microsoft YaHei"/>
                 <a:ea typeface="Microsoft YaHei"/>
@@ -17233,7 +17538,7 @@
                       </a:solidFill>
                     </a:lnB>
                     <a:solidFill>
-                      <a:srgbClr val="1D4ED8"/>
+                      <a:srgbClr val="46196B"/>
                     </a:solidFill>
                   </a:tcPr>
                 </a:tc>
@@ -17278,7 +17583,7 @@
                       </a:solidFill>
                     </a:lnB>
                     <a:solidFill>
-                      <a:srgbClr val="1D4ED8"/>
+                      <a:srgbClr val="46196B"/>
                     </a:solidFill>
                   </a:tcPr>
                 </a:tc>
@@ -17678,7 +17983,7 @@
           <a:lstStyle/>
           <a:p>
             <a:pPr algn="r"/>
-            <a:fld id="{89A49474-FA67-469A-B126-D09C114F6D73}" type="slidenum">
+            <a:fld id="{4FF03DF9-FF25-48D5-98B4-75648E173776}" type="slidenum">
               <a:rPr lang="en-US" sz="1000">
                 <a:solidFill>
                   <a:srgbClr val="9AA3B0"/>
@@ -17820,7 +18125,7 @@
             <a:r>
               <a:rPr sz="1200" b="1">
                 <a:solidFill>
-                  <a:srgbClr val="1D4ED8"/>
+                  <a:srgbClr val="46196B"/>
                 </a:solidFill>
                 <a:latin typeface="Microsoft YaHei"/>
                 <a:ea typeface="Microsoft YaHei"/>
@@ -18070,11 +18375,11 @@
             </a:avLst>
           </a:prstGeom>
           <a:solidFill>
-            <a:srgbClr val="EDE9FE"/>
+            <a:srgbClr val="B6CCF2"/>
           </a:solidFill>
           <a:ln w="19050">
             <a:solidFill>
-              <a:srgbClr val="6D28D9"/>
+              <a:srgbClr val="1E50C8"/>
             </a:solidFill>
           </a:ln>
           <a:effectLst/>
@@ -18101,7 +18406,7 @@
             <a:r>
               <a:rPr sz="1200" b="1">
                 <a:solidFill>
-                  <a:srgbClr val="5B21B6"/>
+                  <a:srgbClr val="15307A"/>
                 </a:solidFill>
                 <a:latin typeface="Microsoft YaHei"/>
                 <a:ea typeface="Microsoft YaHei"/>
@@ -18115,7 +18420,7 @@
             <a:r>
               <a:rPr sz="1200" b="1">
                 <a:solidFill>
-                  <a:srgbClr val="5B21B6"/>
+                  <a:srgbClr val="15307A"/>
                 </a:solidFill>
                 <a:latin typeface="Microsoft YaHei"/>
                 <a:ea typeface="Microsoft YaHei"/>
@@ -18362,11 +18667,11 @@
             </a:avLst>
           </a:prstGeom>
           <a:solidFill>
-            <a:srgbClr val="DBEAFE"/>
+            <a:srgbClr val="D4C2E5"/>
           </a:solidFill>
           <a:ln w="19050">
             <a:solidFill>
-              <a:srgbClr val="1D4ED8"/>
+              <a:srgbClr val="46196B"/>
             </a:solidFill>
           </a:ln>
           <a:effectLst/>
@@ -18393,7 +18698,7 @@
             <a:r>
               <a:rPr sz="1200" b="1">
                 <a:solidFill>
-                  <a:srgbClr val="1E3A8A"/>
+                  <a:srgbClr val="2C0E48"/>
                 </a:solidFill>
                 <a:latin typeface="Microsoft YaHei"/>
                 <a:ea typeface="Microsoft YaHei"/>
@@ -18421,11 +18726,11 @@
             </a:avLst>
           </a:prstGeom>
           <a:solidFill>
-            <a:srgbClr val="CCFBF1"/>
+            <a:srgbClr val="9FE2D4"/>
           </a:solidFill>
           <a:ln w="19050">
             <a:solidFill>
-              <a:srgbClr val="0D9488"/>
+              <a:srgbClr val="0B7D72"/>
             </a:solidFill>
           </a:ln>
           <a:effectLst/>
@@ -18452,7 +18757,7 @@
             <a:r>
               <a:rPr sz="1200" b="1">
                 <a:solidFill>
-                  <a:srgbClr val="115E59"/>
+                  <a:srgbClr val="084A43"/>
                 </a:solidFill>
                 <a:latin typeface="Microsoft YaHei"/>
                 <a:ea typeface="Microsoft YaHei"/>
@@ -18480,11 +18785,11 @@
             </a:avLst>
           </a:prstGeom>
           <a:solidFill>
-            <a:srgbClr val="FFEDD5"/>
+            <a:srgbClr val="F6CD9E"/>
           </a:solidFill>
           <a:ln w="19050">
             <a:solidFill>
-              <a:srgbClr val="EA580C"/>
+              <a:srgbClr val="D14E0A"/>
             </a:solidFill>
           </a:ln>
           <a:effectLst/>
@@ -18511,7 +18816,7 @@
             <a:r>
               <a:rPr sz="1200" b="1">
                 <a:solidFill>
-                  <a:srgbClr val="9A3412"/>
+                  <a:srgbClr val="7E2E07"/>
                 </a:solidFill>
                 <a:latin typeface="Microsoft YaHei"/>
                 <a:ea typeface="Microsoft YaHei"/>
@@ -18539,11 +18844,11 @@
             </a:avLst>
           </a:prstGeom>
           <a:solidFill>
-            <a:srgbClr val="FEE2E2"/>
+            <a:srgbClr val="E6ADAD"/>
           </a:solidFill>
           <a:ln w="19050">
             <a:solidFill>
-              <a:srgbClr val="DC2626"/>
+              <a:srgbClr val="BE1E1E"/>
             </a:solidFill>
           </a:ln>
           <a:effectLst/>
@@ -18570,7 +18875,7 @@
             <a:r>
               <a:rPr sz="1200" b="1">
                 <a:solidFill>
-                  <a:srgbClr val="991B1B"/>
+                  <a:srgbClr val="7E1414"/>
                 </a:solidFill>
                 <a:latin typeface="Microsoft YaHei"/>
                 <a:ea typeface="Microsoft YaHei"/>
@@ -18826,7 +19131,7 @@
           <a:lstStyle/>
           <a:p>
             <a:pPr algn="r"/>
-            <a:fld id="{8EFAB514-9CA8-4D98-AC96-2B31006639CA}" type="slidenum">
+            <a:fld id="{F53ACA2C-044D-442A-9E35-20E8312444B5}" type="slidenum">
               <a:rPr lang="en-US" sz="1000">
                 <a:solidFill>
                   <a:srgbClr val="9AA3B0"/>
@@ -18968,7 +19273,7 @@
             <a:r>
               <a:rPr sz="1200" b="1">
                 <a:solidFill>
-                  <a:srgbClr val="1D4ED8"/>
+                  <a:srgbClr val="46196B"/>
                 </a:solidFill>
                 <a:latin typeface="Microsoft YaHei"/>
                 <a:ea typeface="Microsoft YaHei"/>
@@ -19043,7 +19348,7 @@
                       </a:solidFill>
                     </a:lnB>
                     <a:solidFill>
-                      <a:srgbClr val="1D4ED8"/>
+                      <a:srgbClr val="46196B"/>
                     </a:solidFill>
                   </a:tcPr>
                 </a:tc>
@@ -19088,7 +19393,7 @@
                       </a:solidFill>
                     </a:lnB>
                     <a:solidFill>
-                      <a:srgbClr val="1D4ED8"/>
+                      <a:srgbClr val="46196B"/>
                     </a:solidFill>
                   </a:tcPr>
                 </a:tc>
@@ -19856,7 +20161,7 @@
           <a:lstStyle/>
           <a:p>
             <a:pPr algn="r"/>
-            <a:fld id="{35BB1B18-C49D-42A8-9D90-08A772F588D3}" type="slidenum">
+            <a:fld id="{A9E1E454-C254-4337-9D8E-47C9B598418F}" type="slidenum">
               <a:rPr lang="en-US" sz="1000">
                 <a:solidFill>
                   <a:srgbClr val="9AA3B0"/>
@@ -19998,7 +20303,7 @@
             <a:r>
               <a:rPr sz="1200" b="1">
                 <a:solidFill>
-                  <a:srgbClr val="1D4ED8"/>
+                  <a:srgbClr val="46196B"/>
                 </a:solidFill>
                 <a:latin typeface="Microsoft YaHei"/>
                 <a:ea typeface="Microsoft YaHei"/>
@@ -20529,11 +20834,11 @@
             </a:avLst>
           </a:prstGeom>
           <a:solidFill>
-            <a:srgbClr val="1D4ED8"/>
+            <a:srgbClr val="46196B"/>
           </a:solidFill>
           <a:ln w="19050">
             <a:solidFill>
-              <a:srgbClr val="1D4ED8"/>
+              <a:srgbClr val="46196B"/>
             </a:solidFill>
           </a:ln>
           <a:effectLst/>
@@ -20602,11 +20907,11 @@
             </a:avLst>
           </a:prstGeom>
           <a:solidFill>
-            <a:srgbClr val="CCFBF1"/>
+            <a:srgbClr val="9FE2D4"/>
           </a:solidFill>
           <a:ln w="19050">
             <a:solidFill>
-              <a:srgbClr val="0D9488"/>
+              <a:srgbClr val="0B7D72"/>
             </a:solidFill>
           </a:ln>
           <a:effectLst/>
@@ -20633,7 +20938,7 @@
             <a:r>
               <a:rPr sz="1150" b="1">
                 <a:solidFill>
-                  <a:srgbClr val="115E59"/>
+                  <a:srgbClr val="084A43"/>
                 </a:solidFill>
                 <a:latin typeface="Microsoft YaHei"/>
                 <a:ea typeface="Microsoft YaHei"/>
@@ -20661,11 +20966,11 @@
             </a:avLst>
           </a:prstGeom>
           <a:solidFill>
-            <a:srgbClr val="CCFBF1"/>
+            <a:srgbClr val="9FE2D4"/>
           </a:solidFill>
           <a:ln w="19050">
             <a:solidFill>
-              <a:srgbClr val="0D9488"/>
+              <a:srgbClr val="0B7D72"/>
             </a:solidFill>
           </a:ln>
           <a:effectLst/>
@@ -20692,7 +20997,7 @@
             <a:r>
               <a:rPr sz="1150" b="1">
                 <a:solidFill>
-                  <a:srgbClr val="115E59"/>
+                  <a:srgbClr val="084A43"/>
                 </a:solidFill>
                 <a:latin typeface="Microsoft YaHei"/>
                 <a:ea typeface="Microsoft YaHei"/>
@@ -20720,11 +21025,11 @@
             </a:avLst>
           </a:prstGeom>
           <a:solidFill>
-            <a:srgbClr val="FEE2E2"/>
+            <a:srgbClr val="E6ADAD"/>
           </a:solidFill>
           <a:ln w="19050">
             <a:solidFill>
-              <a:srgbClr val="DC2626"/>
+              <a:srgbClr val="BE1E1E"/>
             </a:solidFill>
           </a:ln>
           <a:effectLst/>
@@ -20751,7 +21056,7 @@
             <a:r>
               <a:rPr sz="1150" b="1">
                 <a:solidFill>
-                  <a:srgbClr val="991B1B"/>
+                  <a:srgbClr val="7E1414"/>
                 </a:solidFill>
                 <a:latin typeface="Microsoft YaHei"/>
                 <a:ea typeface="Microsoft YaHei"/>
@@ -20933,7 +21238,7 @@
           <a:lstStyle/>
           <a:p>
             <a:pPr algn="r"/>
-            <a:fld id="{4ABC1A06-EAA3-4DCF-A80C-D9205131F43F}" type="slidenum">
+            <a:fld id="{7C52BB60-4858-43A7-9626-98883898E89D}" type="slidenum">
               <a:rPr lang="en-US" sz="1000">
                 <a:solidFill>
                   <a:srgbClr val="9AA3B0"/>
@@ -21030,7 +21335,7 @@
             <a:avLst/>
           </a:prstGeom>
           <a:solidFill>
-            <a:srgbClr val="1D4ED8"/>
+            <a:srgbClr val="46196B"/>
           </a:solidFill>
           <a:ln>
             <a:noFill/>
@@ -21238,7 +21543,7 @@
             <a:avLst/>
           </a:prstGeom>
           <a:solidFill>
-            <a:srgbClr val="EA580C"/>
+            <a:srgbClr val="D14E0A"/>
           </a:solidFill>
           <a:ln>
             <a:noFill/>
@@ -21282,7 +21587,7 @@
             <a:avLst/>
           </a:prstGeom>
           <a:solidFill>
-            <a:srgbClr val="EA580C"/>
+            <a:srgbClr val="D14E0A"/>
           </a:solidFill>
           <a:ln>
             <a:noFill/>
@@ -21367,7 +21672,7 @@
             <a:avLst/>
           </a:prstGeom>
           <a:solidFill>
-            <a:srgbClr val="EA580C"/>
+            <a:srgbClr val="D14E0A"/>
           </a:solidFill>
           <a:ln>
             <a:noFill/>
@@ -21452,7 +21757,7 @@
             <a:avLst/>
           </a:prstGeom>
           <a:solidFill>
-            <a:srgbClr val="EA580C"/>
+            <a:srgbClr val="D14E0A"/>
           </a:solidFill>
           <a:ln>
             <a:noFill/>
@@ -21537,7 +21842,7 @@
             <a:avLst/>
           </a:prstGeom>
           <a:solidFill>
-            <a:srgbClr val="EA580C"/>
+            <a:srgbClr val="D14E0A"/>
           </a:solidFill>
           <a:ln>
             <a:noFill/>
@@ -21622,7 +21927,7 @@
             <a:avLst/>
           </a:prstGeom>
           <a:solidFill>
-            <a:srgbClr val="EA580C"/>
+            <a:srgbClr val="D14E0A"/>
           </a:solidFill>
           <a:ln>
             <a:noFill/>
@@ -21707,7 +22012,7 @@
             <a:avLst/>
           </a:prstGeom>
           <a:solidFill>
-            <a:srgbClr val="EA580C"/>
+            <a:srgbClr val="D14E0A"/>
           </a:solidFill>
           <a:ln>
             <a:noFill/>
@@ -21792,7 +22097,7 @@
             <a:avLst/>
           </a:prstGeom>
           <a:solidFill>
-            <a:srgbClr val="EA580C"/>
+            <a:srgbClr val="D14E0A"/>
           </a:solidFill>
           <a:ln>
             <a:noFill/>

</xml_diff>

<commit_message>
deck: deeper OA pass — replace 3 more drawn schematics with real openly-licensed figures + multi-figure support + captions + DOIs
2.2 VeriHGN congestion (CC BY 4.0); 2.4 TWO figs UltraSPARC T1 die (CC BY-SA 3.0) + macro-placement comparison (CC BY-SA 4.0); 3.2 PARSAC hierarchical block floorplan (CC BY-SA 4.0). New deck features: split figs=[fg(...)] multi-image (side-by-side, each captioned), caption= 图注, _split_figs/_psplit_figs. Refs split into 参考文献 + 图片来源(Image Credits) page with DOIs. All licenses re-verified on source pages. Remaining drawn: 2.6 halo / 4.7 IR-on-layout (no verified OA figure).

Co-Authored-By: Claude Opus 4.8 <noreply@anthropic.com>
</commit_message>
<xml_diff>
--- a/IC_Backend_Notes/slides/05_Floorplan - 副本.pptx
+++ b/IC_Backend_Notes/slides/05_Floorplan - 副本.pptx
@@ -727,7 +727,7 @@
                 <a:ea typeface="Microsoft YaHei"/>
                 <a:cs typeface="Microsoft YaHei"/>
               </a:rPr>
-              <a:t>数字 IC 后端 · 从 RTL 到 GDS · DVD Lecture 6</a:t>
+              <a:t>数字 IC 后端 · 从 RTL 到 GDS</a:t>
             </a:r>
           </a:p>
         </p:txBody>
@@ -935,7 +935,7 @@
                 <a:ea typeface="Microsoft YaHei"/>
                 <a:cs typeface="Microsoft YaHei"/>
               </a:rPr>
-              <a:t>整理 J.C  ·  源自 Digital VLSI Design (DVD), Prof. Adam Teman, Bar-Ilan University (83-612)</a:t>
+              <a:t>整理 J.C</a:t>
             </a:r>
           </a:p>
         </p:txBody>
@@ -1120,7 +1120,7 @@
                 <a:ea typeface="Microsoft YaHei"/>
                 <a:cs typeface="Microsoft YaHei"/>
               </a:rPr>
-              <a:t>▪  几何由外到内：Die ＞ IO/Pad Ring ＞ Core ＞（宏 + 标准单元行）</a:t>
+              <a:t>芯片几何由外到内：晶粒 Die ＞ IO / 焊盘环 ＞ 核心区 Core ＞（宏单元 + 标准单元行）。IO 引脚常由前端、系统或封装侧先提出，但物理设计必须参与评审。</a:t>
             </a:r>
           </a:p>
           <a:p>
@@ -1141,7 +1141,7 @@
                 <a:ea typeface="Microsoft YaHei"/>
                 <a:cs typeface="Microsoft YaHei"/>
               </a:rPr>
-              <a:t>▪  IO 引脚由前端 / 系统 / 封装提出，但物理设计必须参与评审</a:t>
+              <a:t>原因有二：一是 IO 不像逻辑晶体管随工艺快速缩小，IO 单元与焊盘面积非常贵；二是 IO 不只传信号还负责供电，电源 / 地焊盘的数量与位置直接影响 IR 压降与 EM。</a:t>
             </a:r>
           </a:p>
           <a:p>
@@ -1162,77 +1162,14 @@
                 <a:ea typeface="Microsoft YaHei"/>
                 <a:cs typeface="Microsoft YaHei"/>
               </a:rPr>
-              <a:t>▪  原因一：IO 不像逻辑随工艺缩小，IO 单元与焊盘面积非常贵</a:t>
-            </a:r>
-          </a:p>
-          <a:p>
-            <a:pPr algn="l">
-              <a:lnSpc>
-                <a:spcPct val="116000"/>
-              </a:lnSpc>
-              <a:spcAft>
-                <a:spcPts val="800"/>
-              </a:spcAft>
-            </a:pPr>
-            <a:r>
-              <a:rPr sz="1400" b="0">
-                <a:solidFill>
-                  <a:srgbClr val="1A1F2B"/>
-                </a:solidFill>
-                <a:latin typeface="Microsoft YaHei"/>
-                <a:ea typeface="Microsoft YaHei"/>
-                <a:cs typeface="Microsoft YaHei"/>
-              </a:rPr>
-              <a:t>▪  原因二：IO 还负责供电，电源 / 地焊盘的数量与位置直接影响 IR 与 EM</a:t>
-            </a:r>
-          </a:p>
-          <a:p>
-            <a:pPr algn="l">
-              <a:lnSpc>
-                <a:spcPct val="116000"/>
-              </a:lnSpc>
-              <a:spcAft>
-                <a:spcPts val="800"/>
-              </a:spcAft>
-            </a:pPr>
-            <a:r>
-              <a:rPr sz="1400" b="0">
-                <a:solidFill>
-                  <a:srgbClr val="1A1F2B"/>
-                </a:solidFill>
-                <a:latin typeface="Microsoft YaHei"/>
-                <a:ea typeface="Microsoft YaHei"/>
-                <a:cs typeface="Microsoft YaHei"/>
-              </a:rPr>
-              <a:t>▪  核心受限：尺寸由逻辑规模 / 宏 / 布线资源决定 → 优化利用率、宏摆放与布线资源</a:t>
-            </a:r>
-          </a:p>
-          <a:p>
-            <a:pPr algn="l">
-              <a:lnSpc>
-                <a:spcPct val="116000"/>
-              </a:lnSpc>
-              <a:spcAft>
-                <a:spcPts val="800"/>
-              </a:spcAft>
-            </a:pPr>
-            <a:r>
-              <a:rPr sz="1400" b="0">
-                <a:solidFill>
-                  <a:srgbClr val="1A1F2B"/>
-                </a:solidFill>
-                <a:latin typeface="Microsoft YaHei"/>
-                <a:ea typeface="Microsoft YaHei"/>
-                <a:cs typeface="Microsoft YaHei"/>
-              </a:rPr>
-              <a:t>▪  焊盘受限：尺寸由 IO 数 / 焊盘间距 / 封装决定，晶粒不能再小 → 优化 IO 环与封装协同</a:t>
+              <a:t>选尺寸先判断是核心受限还是焊盘受限：核心受限由逻辑规模、宏与布线资源决定芯片大小，重点优化利用率与摆放；焊盘受限由 IO 数量、焊盘间距与封装引脚决定、晶粒已不能再小，重点优化 IO 环与封装协同。</a:t>
             </a:r>
           </a:p>
         </p:txBody>
       </p:sp>
       <p:pic>
         <p:nvPicPr>
-          <p:cNvPr id="6" name="Picture 5" descr="f03_geometry.png"/>
+          <p:cNvPr id="6" name="Picture 5" descr="ext_die_i9_cc0.jpg"/>
           <p:cNvPicPr>
             <a:picLocks noChangeAspect="1"/>
           </p:cNvPicPr>
@@ -1246,8 +1183,8 @@
         </p:blipFill>
         <p:spPr>
           <a:xfrm>
-            <a:off x="5681540" y="1554480"/>
-            <a:ext cx="5873359" cy="4800600"/>
+            <a:off x="5486400" y="2512185"/>
+            <a:ext cx="6263640" cy="2885189"/>
           </a:xfrm>
           <a:prstGeom prst="rect">
             <a:avLst/>
@@ -1257,6 +1194,47 @@
       <p:sp>
         <p:nvSpPr>
           <p:cNvPr id="7" name="TextBox 6"/>
+          <p:cNvSpPr txBox="1"/>
+          <p:nvPr/>
+        </p:nvSpPr>
+        <p:spPr>
+          <a:xfrm>
+            <a:off x="5486400" y="6382512"/>
+            <a:ext cx="6263640" cy="274320"/>
+          </a:xfrm>
+          <a:prstGeom prst="rect">
+            <a:avLst/>
+          </a:prstGeom>
+          <a:noFill/>
+        </p:spPr>
+        <p:txBody>
+          <a:bodyPr wrap="square" anchor="t" lIns="25400" rIns="25400" tIns="25400" bIns="25400">
+            <a:spAutoFit/>
+          </a:bodyPr>
+          <a:lstStyle/>
+          <a:p>
+            <a:pPr algn="r">
+              <a:spcAft>
+                <a:spcPts val="600"/>
+              </a:spcAft>
+            </a:pPr>
+            <a:r>
+              <a:rPr sz="900" b="0">
+                <a:solidFill>
+                  <a:srgbClr val="6B7280"/>
+                </a:solidFill>
+                <a:latin typeface="Microsoft YaHei"/>
+                <a:ea typeface="Microsoft YaHei"/>
+                <a:cs typeface="Microsoft YaHei"/>
+              </a:rPr>
+              <a:t>来源：Intel i9-13900K die · Fritzchens Fritz / JmsDoug · CC0 · Wikimedia</a:t>
+            </a:r>
+          </a:p>
+        </p:txBody>
+      </p:sp>
+      <p:sp>
+        <p:nvSpPr>
+          <p:cNvPr id="8" name="TextBox 7"/>
           <p:cNvSpPr txBox="1"/>
           <p:nvPr/>
         </p:nvSpPr>
@@ -1277,7 +1255,7 @@
           <a:lstStyle/>
           <a:p>
             <a:pPr algn="r"/>
-            <a:fld id="{3D9AC620-ED5E-4753-A684-CAC8EB1DCB07}" type="slidenum">
+            <a:fld id="{8D9AC73B-3779-41B9-B05A-0292D943A81B}" type="slidenum">
               <a:rPr lang="en-US" sz="1000">
                 <a:solidFill>
                   <a:srgbClr val="9AA3B0"/>
@@ -1563,7 +1541,7 @@
           <a:lstStyle/>
           <a:p>
             <a:pPr algn="r"/>
-            <a:fld id="{C20E49C7-0FE7-43FA-BB5A-12866AC7536E}" type="slidenum">
+            <a:fld id="{D6B2CC82-306B-4FD9-8693-34F425358B28}" type="slidenum">
               <a:rPr lang="en-US" sz="1000">
                 <a:solidFill>
                   <a:srgbClr val="9AA3B0"/>
@@ -3088,7 +3066,7 @@
           <a:lstStyle/>
           <a:p>
             <a:pPr algn="r"/>
-            <a:fld id="{172B1ABA-8AD7-4260-A0E7-B97972BCC4E7}" type="slidenum">
+            <a:fld id="{FD2171DB-AC36-4510-AA79-B02E6FE434E5}" type="slidenum">
               <a:rPr lang="en-US" sz="1000">
                 <a:solidFill>
                   <a:srgbClr val="9AA3B0"/>
@@ -3437,7 +3415,7 @@
           <a:lstStyle/>
           <a:p>
             <a:pPr algn="r"/>
-            <a:fld id="{471FD68B-04E4-402F-BE5D-56333875CC88}" type="slidenum">
+            <a:fld id="{C1FAE399-EE9E-47EC-B57F-6FDC0EDD29F5}" type="slidenum">
               <a:rPr lang="en-US" sz="1000">
                 <a:solidFill>
                   <a:srgbClr val="9AA3B0"/>
@@ -4325,7 +4303,7 @@
           <a:lstStyle/>
           <a:p>
             <a:pPr algn="r"/>
-            <a:fld id="{580B34B3-BF07-4A98-870A-5F2DFC691422}" type="slidenum">
+            <a:fld id="{6D3C1CDF-E65E-4021-BBAB-0C88A51DF74A}" type="slidenum">
               <a:rPr lang="en-US" sz="1000">
                 <a:solidFill>
                   <a:srgbClr val="9AA3B0"/>
@@ -4674,7 +4652,7 @@
           <a:lstStyle/>
           <a:p>
             <a:pPr algn="r"/>
-            <a:fld id="{7EF33A2B-6EDF-4D5B-BCD0-E74BED0B514A}" type="slidenum">
+            <a:fld id="{06C38842-2BB9-40E0-A19C-BE6EBD0719C6}" type="slidenum">
               <a:rPr lang="en-US" sz="1000">
                 <a:solidFill>
                   <a:srgbClr val="9AA3B0"/>
@@ -5043,7 +5021,7 @@
           <a:lstStyle/>
           <a:p>
             <a:pPr algn="r"/>
-            <a:fld id="{0D01850F-55DF-4BE3-A9B4-5DC6E2A565D6}" type="slidenum">
+            <a:fld id="{821460AE-D0F9-4173-A2B6-D0E6EFFD972D}" type="slidenum">
               <a:rPr lang="en-US" sz="1000">
                 <a:solidFill>
                   <a:srgbClr val="9AA3B0"/>
@@ -6764,7 +6742,7 @@
           <a:lstStyle/>
           <a:p>
             <a:pPr algn="r"/>
-            <a:fld id="{AB900C57-1A24-4407-9C89-0742FD320398}" type="slidenum">
+            <a:fld id="{19DDB01F-B288-4A2D-A5C3-2A7690D1F795}" type="slidenum">
               <a:rPr lang="en-US" sz="1000">
                 <a:solidFill>
                   <a:srgbClr val="9AA3B0"/>
@@ -6956,7 +6934,7 @@
                 <a:ea typeface="Microsoft YaHei"/>
                 <a:cs typeface="Microsoft YaHei"/>
               </a:rPr>
-              <a:t>▪  芯片级约束必须映射成模块级约束</a:t>
+              <a:t>芯片级约束必须映射成模块级约束。例如顶层某输入到模块的路径预算为 1.5 ns，模块实现时就要在模块边界建立对应的输入 / 输出延迟、时钟不确定性、负载与驱动单元约束。</a:t>
             </a:r>
           </a:p>
           <a:p>
@@ -6977,7 +6955,7 @@
                 <a:ea typeface="Microsoft YaHei"/>
                 <a:cs typeface="Microsoft YaHei"/>
               </a:rPr>
-              <a:t>▪  示例：顶层某输入到模块的路径预算 1.5 ns，模块实现时要在边界还原它</a:t>
+              <a:t>预算合理时，各模块独立收敛后全芯片才容易收敛；预算不合理时，单个模块看似通过，全芯片仍可能失败。</a:t>
             </a:r>
           </a:p>
           <a:p>
@@ -6998,91 +6976,7 @@
                 <a:ea typeface="Microsoft YaHei"/>
                 <a:cs typeface="Microsoft YaHei"/>
               </a:rPr>
-              <a:t>▪  在模块边界建立输入 / 输出延迟、时钟不确定度、负载与驱动单元约束</a:t>
-            </a:r>
-          </a:p>
-          <a:p>
-            <a:pPr algn="l">
-              <a:lnSpc>
-                <a:spcPct val="116000"/>
-              </a:lnSpc>
-              <a:spcAft>
-                <a:spcPts val="800"/>
-              </a:spcAft>
-            </a:pPr>
-            <a:r>
-              <a:rPr sz="1400" b="0">
-                <a:solidFill>
-                  <a:srgbClr val="1A1F2B"/>
-                </a:solidFill>
-                <a:latin typeface="Microsoft YaHei"/>
-                <a:ea typeface="Microsoft YaHei"/>
-                <a:cs typeface="Microsoft YaHei"/>
-              </a:rPr>
-              <a:t>▪  预算合理 → 各模块独立收敛后，全芯片才容易收敛</a:t>
-            </a:r>
-          </a:p>
-          <a:p>
-            <a:pPr algn="l">
-              <a:lnSpc>
-                <a:spcPct val="116000"/>
-              </a:lnSpc>
-              <a:spcAft>
-                <a:spcPts val="800"/>
-              </a:spcAft>
-            </a:pPr>
-            <a:r>
-              <a:rPr sz="1400" b="0">
-                <a:solidFill>
-                  <a:srgbClr val="1A1F2B"/>
-                </a:solidFill>
-                <a:latin typeface="Microsoft YaHei"/>
-                <a:ea typeface="Microsoft YaHei"/>
-                <a:cs typeface="Microsoft YaHei"/>
-              </a:rPr>
-              <a:t>▪  预算不合理 → 单模块看似通过，全芯片仍可能失败</a:t>
-            </a:r>
-          </a:p>
-          <a:p>
-            <a:pPr algn="l">
-              <a:lnSpc>
-                <a:spcPct val="116000"/>
-              </a:lnSpc>
-              <a:spcAft>
-                <a:spcPts val="800"/>
-              </a:spcAft>
-            </a:pPr>
-            <a:r>
-              <a:rPr sz="1400" b="0">
-                <a:solidFill>
-                  <a:srgbClr val="1A1F2B"/>
-                </a:solidFill>
-                <a:latin typeface="Microsoft YaHei"/>
-                <a:ea typeface="Microsoft YaHei"/>
-                <a:cs typeface="Microsoft YaHei"/>
-              </a:rPr>
-              <a:t>▪  ILM（接口逻辑模型）只保留接口相关逻辑、隐藏模块内部细节</a:t>
-            </a:r>
-          </a:p>
-          <a:p>
-            <a:pPr algn="l">
-              <a:lnSpc>
-                <a:spcPct val="116000"/>
-              </a:lnSpc>
-              <a:spcAft>
-                <a:spcPts val="800"/>
-              </a:spcAft>
-            </a:pPr>
-            <a:r>
-              <a:rPr sz="1400" b="0">
-                <a:solidFill>
-                  <a:srgbClr val="1A1F2B"/>
-                </a:solidFill>
-                <a:latin typeface="Microsoft YaHei"/>
-                <a:ea typeface="Microsoft YaHei"/>
-                <a:cs typeface="Microsoft YaHei"/>
-              </a:rPr>
-              <a:t>▪  ETM（抽取时序模型）也提供抽象时序模型；二者都让全芯片分析更快可控</a:t>
+              <a:t>接口逻辑模型（ILM）保留模块边界附近与接口相关的逻辑、隐藏内部细节；抽取时序模型（ETM）也提供模块的抽象时序模型。二者都让全芯片时序分析更快、更可控。</a:t>
             </a:r>
           </a:p>
         </p:txBody>
@@ -7134,7 +7028,7 @@
           <a:lstStyle/>
           <a:p>
             <a:pPr algn="r"/>
-            <a:fld id="{71AFE404-E83A-428B-861F-6838B02A23B1}" type="slidenum">
+            <a:fld id="{B79FCC7F-B67F-471B-9628-72121FAE80FC}" type="slidenum">
               <a:rPr lang="en-US" sz="1000">
                 <a:solidFill>
                   <a:srgbClr val="9AA3B0"/>
@@ -8049,7 +7943,7 @@
           <a:lstStyle/>
           <a:p>
             <a:pPr algn="r"/>
-            <a:fld id="{CB1D2EC1-4CB7-4B7F-AF8E-1CC84E9DF10B}" type="slidenum">
+            <a:fld id="{D03DBFA8-BB6A-4563-BF98-066FB1D27943}" type="slidenum">
               <a:rPr lang="en-US" sz="1000">
                 <a:solidFill>
                   <a:srgbClr val="9AA3B0"/>
@@ -8290,7 +8184,7 @@
       </p:sp>
       <p:pic>
         <p:nvPicPr>
-          <p:cNvPr id="6" name="Picture 5" descr="f13_iopad.png"/>
+          <p:cNvPr id="6" name="Picture 5" descr="ext_wirebond_ccbysa.jpg"/>
           <p:cNvPicPr>
             <a:picLocks noChangeAspect="1"/>
           </p:cNvPicPr>
@@ -8304,8 +8198,8 @@
         </p:blipFill>
         <p:spPr>
           <a:xfrm>
-            <a:off x="5486400" y="1752495"/>
-            <a:ext cx="6263640" cy="4404568"/>
+            <a:off x="5617845" y="1554480"/>
+            <a:ext cx="6000750" cy="4800600"/>
           </a:xfrm>
           <a:prstGeom prst="rect">
             <a:avLst/>
@@ -8315,6 +8209,47 @@
       <p:sp>
         <p:nvSpPr>
           <p:cNvPr id="7" name="TextBox 6"/>
+          <p:cNvSpPr txBox="1"/>
+          <p:nvPr/>
+        </p:nvSpPr>
+        <p:spPr>
+          <a:xfrm>
+            <a:off x="5486400" y="6382512"/>
+            <a:ext cx="6263640" cy="274320"/>
+          </a:xfrm>
+          <a:prstGeom prst="rect">
+            <a:avLst/>
+          </a:prstGeom>
+          <a:noFill/>
+        </p:spPr>
+        <p:txBody>
+          <a:bodyPr wrap="square" anchor="t" lIns="25400" rIns="25400" tIns="25400" bIns="25400">
+            <a:spAutoFit/>
+          </a:bodyPr>
+          <a:lstStyle/>
+          <a:p>
+            <a:pPr algn="r">
+              <a:spcAft>
+                <a:spcPts val="600"/>
+              </a:spcAft>
+            </a:pPr>
+            <a:r>
+              <a:rPr sz="900" b="0">
+                <a:solidFill>
+                  <a:srgbClr val="6B7280"/>
+                </a:solidFill>
+                <a:latin typeface="Microsoft YaHei"/>
+                <a:ea typeface="Microsoft YaHei"/>
+                <a:cs typeface="Microsoft YaHei"/>
+              </a:rPr>
+              <a:t>来源：Wire-bond 实拍 · Mister rf · CC BY-SA 4.0 · Wikimedia</a:t>
+            </a:r>
+          </a:p>
+        </p:txBody>
+      </p:sp>
+      <p:sp>
+        <p:nvSpPr>
+          <p:cNvPr id="8" name="TextBox 7"/>
           <p:cNvSpPr txBox="1"/>
           <p:nvPr/>
         </p:nvSpPr>
@@ -8335,7 +8270,7 @@
           <a:lstStyle/>
           <a:p>
             <a:pPr algn="r"/>
-            <a:fld id="{3CD8F268-4DF2-4E9D-A7CE-CFF53D76A45C}" type="slidenum">
+            <a:fld id="{5DAC4248-A2CD-49B4-97D9-EE00592469BF}" type="slidenum">
               <a:rPr lang="en-US" sz="1000">
                 <a:solidFill>
                   <a:srgbClr val="9AA3B0"/>
@@ -9486,14 +9421,14 @@
                 <a:ea typeface="Microsoft YaHei"/>
                 <a:cs typeface="Microsoft YaHei"/>
               </a:rPr>
-              <a:t>因此电源规划从 floorplan 阶段就开始，而不是等布线之后再补救。</a:t>
+              <a:t>因此电源规划从 floorplan 阶段就开始，而不是等布线之后再补救。右图是一颗真实芯片的顶层金属，几乎整层都用于供电网。</a:t>
             </a:r>
           </a:p>
         </p:txBody>
       </p:sp>
       <p:pic>
         <p:nvPicPr>
-          <p:cNvPr id="6" name="Picture 5" descr="f08_power.png"/>
+          <p:cNvPr id="6" name="Picture 5" descr="ext_pdn_bitfury_ccby.jpg"/>
           <p:cNvPicPr>
             <a:picLocks noChangeAspect="1"/>
           </p:cNvPicPr>
@@ -9507,8 +9442,8 @@
         </p:blipFill>
         <p:spPr>
           <a:xfrm>
-            <a:off x="5486400" y="1676348"/>
-            <a:ext cx="6263640" cy="4556863"/>
+            <a:off x="6221120" y="1554480"/>
+            <a:ext cx="4794199" cy="4800600"/>
           </a:xfrm>
           <a:prstGeom prst="rect">
             <a:avLst/>
@@ -9518,6 +9453,47 @@
       <p:sp>
         <p:nvSpPr>
           <p:cNvPr id="7" name="TextBox 6"/>
+          <p:cNvSpPr txBox="1"/>
+          <p:nvPr/>
+        </p:nvSpPr>
+        <p:spPr>
+          <a:xfrm>
+            <a:off x="5486400" y="6382512"/>
+            <a:ext cx="6263640" cy="274320"/>
+          </a:xfrm>
+          <a:prstGeom prst="rect">
+            <a:avLst/>
+          </a:prstGeom>
+          <a:noFill/>
+        </p:spPr>
+        <p:txBody>
+          <a:bodyPr wrap="square" anchor="t" lIns="25400" rIns="25400" tIns="25400" bIns="25400">
+            <a:spAutoFit/>
+          </a:bodyPr>
+          <a:lstStyle/>
+          <a:p>
+            <a:pPr algn="r">
+              <a:spcAft>
+                <a:spcPts val="600"/>
+              </a:spcAft>
+            </a:pPr>
+            <a:r>
+              <a:rPr sz="900" b="0">
+                <a:solidFill>
+                  <a:srgbClr val="6B7280"/>
+                </a:solidFill>
+                <a:latin typeface="Microsoft YaHei"/>
+                <a:ea typeface="Microsoft YaHei"/>
+                <a:cs typeface="Microsoft YaHei"/>
+              </a:rPr>
+              <a:t>来源：Bitfury 55nm 顶层金属供电网 · ZeptoBars · CC BY 3.0 · Wikimedia</a:t>
+            </a:r>
+          </a:p>
+        </p:txBody>
+      </p:sp>
+      <p:sp>
+        <p:nvSpPr>
+          <p:cNvPr id="8" name="TextBox 7"/>
           <p:cNvSpPr txBox="1"/>
           <p:nvPr/>
         </p:nvSpPr>
@@ -9538,7 +9514,7 @@
           <a:lstStyle/>
           <a:p>
             <a:pPr algn="r"/>
-            <a:fld id="{8758FACF-C825-46E8-B25C-52EB1FF021CA}" type="slidenum">
+            <a:fld id="{150CD64C-9BA4-45E2-BD6E-A3A64EAA5185}" type="slidenum">
               <a:rPr lang="en-US" sz="1000">
                 <a:solidFill>
                   <a:srgbClr val="9AA3B0"/>
@@ -9779,7 +9755,7 @@
       </p:sp>
       <p:pic>
         <p:nvPicPr>
-          <p:cNvPr id="6" name="Picture 5" descr="f09_irem.png"/>
+          <p:cNvPr id="6" name="Picture 5" descr="ext_irdrop_waca_ccby.png"/>
           <p:cNvPicPr>
             <a:picLocks noChangeAspect="1"/>
           </p:cNvPicPr>
@@ -9793,8 +9769,8 @@
         </p:blipFill>
         <p:spPr>
           <a:xfrm>
-            <a:off x="5486400" y="1740229"/>
-            <a:ext cx="6263640" cy="4429101"/>
+            <a:off x="5564074" y="1554480"/>
+            <a:ext cx="6108290" cy="4800600"/>
           </a:xfrm>
           <a:prstGeom prst="rect">
             <a:avLst/>
@@ -9804,6 +9780,47 @@
       <p:sp>
         <p:nvSpPr>
           <p:cNvPr id="7" name="TextBox 6"/>
+          <p:cNvSpPr txBox="1"/>
+          <p:nvPr/>
+        </p:nvSpPr>
+        <p:spPr>
+          <a:xfrm>
+            <a:off x="5486400" y="6382512"/>
+            <a:ext cx="6263640" cy="274320"/>
+          </a:xfrm>
+          <a:prstGeom prst="rect">
+            <a:avLst/>
+          </a:prstGeom>
+          <a:noFill/>
+        </p:spPr>
+        <p:txBody>
+          <a:bodyPr wrap="square" anchor="t" lIns="25400" rIns="25400" tIns="25400" bIns="25400">
+            <a:spAutoFit/>
+          </a:bodyPr>
+          <a:lstStyle/>
+          <a:p>
+            <a:pPr algn="r">
+              <a:spcAft>
+                <a:spcPts val="600"/>
+              </a:spcAft>
+            </a:pPr>
+            <a:r>
+              <a:rPr sz="900" b="0">
+                <a:solidFill>
+                  <a:srgbClr val="6B7280"/>
+                </a:solidFill>
+                <a:latin typeface="Microsoft YaHei"/>
+                <a:ea typeface="Microsoft YaHei"/>
+                <a:cs typeface="Microsoft YaHei"/>
+              </a:rPr>
+              <a:t>来源：IR drop map · WACA-UNet, Seo et al. · arXiv:2507.19197 · CC BY 4.0</a:t>
+            </a:r>
+          </a:p>
+        </p:txBody>
+      </p:sp>
+      <p:sp>
+        <p:nvSpPr>
+          <p:cNvPr id="8" name="TextBox 7"/>
           <p:cNvSpPr txBox="1"/>
           <p:nvPr/>
         </p:nvSpPr>
@@ -9824,7 +9841,7 @@
           <a:lstStyle/>
           <a:p>
             <a:pPr algn="r"/>
-            <a:fld id="{0CAF6D91-E7B7-4D36-B4E3-ECCEA11E811D}" type="slidenum">
+            <a:fld id="{EFED2FEB-97DE-42FC-9067-3D84FE831C0F}" type="slidenum">
               <a:rPr lang="en-US" sz="1000">
                 <a:solidFill>
                   <a:srgbClr val="9AA3B0"/>
@@ -10172,7 +10189,7 @@
           <a:lstStyle/>
           <a:p>
             <a:pPr algn="r"/>
-            <a:fld id="{4A8E33A4-6D26-4A65-BAB0-442046E3E256}" type="slidenum">
+            <a:fld id="{BD918C2C-03E4-4FD3-AF0F-47D8E0F2A300}" type="slidenum">
               <a:rPr lang="en-US" sz="1000">
                 <a:solidFill>
                   <a:srgbClr val="9AA3B0"/>
@@ -11060,7 +11077,7 @@
           <a:lstStyle/>
           <a:p>
             <a:pPr algn="r"/>
-            <a:fld id="{8A5FB7A0-A674-4182-87BB-3382791C08EB}" type="slidenum">
+            <a:fld id="{5AB9D1F9-209F-4FA5-B9B2-313428FDA173}" type="slidenum">
               <a:rPr lang="en-US" sz="1000">
                 <a:solidFill>
                   <a:srgbClr val="9AA3B0"/>
@@ -12222,7 +12239,7 @@
           <a:lstStyle/>
           <a:p>
             <a:pPr algn="r"/>
-            <a:fld id="{8CB7A4C2-0A44-49BB-A011-E8FA6927E2A8}" type="slidenum">
+            <a:fld id="{D6759BC0-5E36-40D0-BFC1-6D8002376A63}" type="slidenum">
               <a:rPr lang="en-US" sz="1000">
                 <a:solidFill>
                   <a:srgbClr val="9AA3B0"/>
@@ -12547,7 +12564,7 @@
           <a:lstStyle/>
           <a:p>
             <a:pPr algn="r"/>
-            <a:fld id="{11ED5538-AE99-4B67-9108-1E328FF70A24}" type="slidenum">
+            <a:fld id="{58BDEFD6-8396-4FF9-ACF7-4439AB0D9084}" type="slidenum">
               <a:rPr lang="en-US" sz="1000">
                 <a:solidFill>
                   <a:srgbClr val="9AA3B0"/>
@@ -12896,7 +12913,7 @@
           <a:lstStyle/>
           <a:p>
             <a:pPr algn="r"/>
-            <a:fld id="{ADA2650E-A7AB-459C-B8EC-040FDBC0F7E1}" type="slidenum">
+            <a:fld id="{5C384DAF-1907-49A3-80CA-3BB7958EBB6B}" type="slidenum">
               <a:rPr lang="en-US" sz="1000">
                 <a:solidFill>
                   <a:srgbClr val="9AA3B0"/>
@@ -14988,7 +15005,7 @@
           <a:lstStyle/>
           <a:p>
             <a:pPr algn="r"/>
-            <a:fld id="{73D875F2-2433-4CDE-9AF5-C3F3014E4147}" type="slidenum">
+            <a:fld id="{E9DB13BF-8425-436A-B03D-2A7EBC4F81C1}" type="slidenum">
               <a:rPr lang="en-US" sz="1000">
                 <a:solidFill>
                   <a:srgbClr val="9AA3B0"/>
@@ -16013,7 +16030,7 @@
           <a:lstStyle/>
           <a:p>
             <a:pPr algn="r"/>
-            <a:fld id="{004AF44E-2BD7-47C1-894F-A03D7A3397D6}" type="slidenum">
+            <a:fld id="{862D3ACA-4FFB-4DA2-A17F-4D03F7CAA875}" type="slidenum">
               <a:rPr lang="en-US" sz="1000">
                 <a:solidFill>
                   <a:srgbClr val="9AA3B0"/>
@@ -16120,7 +16137,7 @@
                 <a:ea typeface="Microsoft YaHei"/>
                 <a:cs typeface="Microsoft YaHei"/>
               </a:rPr>
-              <a:t>选项随版本而异；坑：Innovus margin 四值为 LBRT</a:t>
+              <a:t>选项随工具版本而异；Innovus margin 四值顺序为 L / B / R / T</a:t>
             </a:r>
           </a:p>
         </p:txBody>
@@ -16791,7 +16808,7 @@
           <a:lstStyle/>
           <a:p>
             <a:pPr algn="r"/>
-            <a:fld id="{58A8FCE5-6422-447F-92F4-F423A2DF1237}" type="slidenum">
+            <a:fld id="{F43C85B6-972E-4E85-9A11-567488B7E6EF}" type="slidenum">
               <a:rPr lang="en-US" sz="1000">
                 <a:solidFill>
                   <a:srgbClr val="9AA3B0"/>
@@ -16898,7 +16915,7 @@
                 <a:ea typeface="Microsoft YaHei"/>
                 <a:cs typeface="Microsoft YaHei"/>
               </a:rPr>
-              <a:t>本讲内容与图示来源（引用文献插图时图下另标“来源：…”）</a:t>
+              <a:t>本讲内容与图示来源</a:t>
             </a:r>
           </a:p>
         </p:txBody>
@@ -16953,7 +16970,7 @@
         <p:spPr>
           <a:xfrm>
             <a:off x="640080" y="1627632"/>
-            <a:ext cx="10972800" cy="4754880"/>
+            <a:ext cx="5486400" cy="4754880"/>
           </a:xfrm>
           <a:prstGeom prst="rect">
             <a:avLst/>
@@ -16968,14 +16985,14 @@
           <a:p>
             <a:pPr algn="l">
               <a:lnSpc>
-                <a:spcPct val="120000"/>
+                <a:spcPct val="118000"/>
               </a:lnSpc>
               <a:spcAft>
-                <a:spcPts val="900"/>
-              </a:spcAft>
-            </a:pPr>
-            <a:r>
-              <a:rPr sz="1250" b="0">
+                <a:spcPts val="800"/>
+              </a:spcAft>
+            </a:pPr>
+            <a:r>
+              <a:rPr sz="1200" b="0">
                 <a:solidFill>
                   <a:srgbClr val="1A1F2B"/>
                 </a:solidFill>
@@ -16983,20 +17000,20 @@
                 <a:ea typeface="Microsoft YaHei"/>
                 <a:cs typeface="Microsoft YaHei"/>
               </a:rPr>
-              <a:t>[1]  Adam Teman. Digital VLSI Design (DVD), Lecture 6 — Import Design and Floorplan. Bar-Ilan University, Course 83-612. https://enicslabs.com/academic-courses/dvd-english/</a:t>
+              <a:t>[1]  Adam Teman. Digital VLSI Design (DVD), Lecture 6 — Import Design and Floorplan. Bar-Ilan University (83-612). enicslabs.com/academic-courses/dvd-english</a:t>
             </a:r>
           </a:p>
           <a:p>
             <a:pPr algn="l">
               <a:lnSpc>
-                <a:spcPct val="120000"/>
+                <a:spcPct val="118000"/>
               </a:lnSpc>
               <a:spcAft>
-                <a:spcPts val="900"/>
-              </a:spcAft>
-            </a:pPr>
-            <a:r>
-              <a:rPr sz="1250" b="0">
+                <a:spcPts val="800"/>
+              </a:spcAft>
+            </a:pPr>
+            <a:r>
+              <a:rPr sz="1200" b="0">
                 <a:solidFill>
                   <a:srgbClr val="1A1F2B"/>
                 </a:solidFill>
@@ -17010,14 +17027,14 @@
           <a:p>
             <a:pPr algn="l">
               <a:lnSpc>
-                <a:spcPct val="120000"/>
+                <a:spcPct val="118000"/>
               </a:lnSpc>
               <a:spcAft>
-                <a:spcPts val="900"/>
-              </a:spcAft>
-            </a:pPr>
-            <a:r>
-              <a:rPr sz="1250" b="0">
+                <a:spcPts val="800"/>
+              </a:spcAft>
+            </a:pPr>
+            <a:r>
+              <a:rPr sz="1200" b="0">
                 <a:solidFill>
                   <a:srgbClr val="1A1F2B"/>
                 </a:solidFill>
@@ -17031,14 +17048,14 @@
           <a:p>
             <a:pPr algn="l">
               <a:lnSpc>
-                <a:spcPct val="120000"/>
+                <a:spcPct val="118000"/>
               </a:lnSpc>
               <a:spcAft>
-                <a:spcPts val="900"/>
-              </a:spcAft>
-            </a:pPr>
-            <a:r>
-              <a:rPr sz="1250" b="0">
+                <a:spcPts val="800"/>
+              </a:spcAft>
+            </a:pPr>
+            <a:r>
+              <a:rPr sz="1200" b="0">
                 <a:solidFill>
                   <a:srgbClr val="1A1F2B"/>
                 </a:solidFill>
@@ -17052,14 +17069,14 @@
           <a:p>
             <a:pPr algn="l">
               <a:lnSpc>
-                <a:spcPct val="120000"/>
+                <a:spcPct val="118000"/>
               </a:lnSpc>
               <a:spcAft>
-                <a:spcPts val="900"/>
-              </a:spcAft>
-            </a:pPr>
-            <a:r>
-              <a:rPr sz="1250" b="0">
+                <a:spcPts val="800"/>
+              </a:spcAft>
+            </a:pPr>
+            <a:r>
+              <a:rPr sz="1200" b="0">
                 <a:solidFill>
                   <a:srgbClr val="1A1F2B"/>
                 </a:solidFill>
@@ -17067,7 +17084,7 @@
                 <a:ea typeface="Microsoft YaHei"/>
                 <a:cs typeface="Microsoft YaHei"/>
               </a:rPr>
-              <a:t>[5]  Cadence Innovus User Guide; Synopsys IC Compiler II / Fusion Compiler User Guide（命令与流程参考）.</a:t>
+              <a:t>[5]  Cadence Innovus / Synopsys ICC2 / Fusion Compiler User Guides（命令与流程参考）.</a:t>
             </a:r>
           </a:p>
         </p:txBody>
@@ -17075,6 +17092,134 @@
       <p:sp>
         <p:nvSpPr>
           <p:cNvPr id="6" name="TextBox 5"/>
+          <p:cNvSpPr txBox="1"/>
+          <p:nvPr/>
+        </p:nvSpPr>
+        <p:spPr>
+          <a:xfrm>
+            <a:off x="6309360" y="1627632"/>
+            <a:ext cx="5486400" cy="4754880"/>
+          </a:xfrm>
+          <a:prstGeom prst="rect">
+            <a:avLst/>
+          </a:prstGeom>
+          <a:noFill/>
+        </p:spPr>
+        <p:txBody>
+          <a:bodyPr wrap="square" anchor="t" lIns="25400" rIns="25400" tIns="25400" bIns="25400">
+            <a:normAutofit/>
+          </a:bodyPr>
+          <a:lstStyle/>
+          <a:p>
+            <a:pPr algn="l">
+              <a:lnSpc>
+                <a:spcPct val="118000"/>
+              </a:lnSpc>
+              <a:spcAft>
+                <a:spcPts val="800"/>
+              </a:spcAft>
+            </a:pPr>
+            <a:r>
+              <a:rPr sz="1200" b="0">
+                <a:solidFill>
+                  <a:srgbClr val="1A1F2B"/>
+                </a:solidFill>
+                <a:latin typeface="Microsoft YaHei"/>
+                <a:ea typeface="Microsoft YaHei"/>
+                <a:cs typeface="Microsoft YaHei"/>
+              </a:rPr>
+              <a:t>[6]  图 1.1 Intel 80486DX2 die — Smial, CC BY 3.0, Wikimedia Commons.</a:t>
+            </a:r>
+          </a:p>
+          <a:p>
+            <a:pPr algn="l">
+              <a:lnSpc>
+                <a:spcPct val="118000"/>
+              </a:lnSpc>
+              <a:spcAft>
+                <a:spcPts val="800"/>
+              </a:spcAft>
+            </a:pPr>
+            <a:r>
+              <a:rPr sz="1200" b="0">
+                <a:solidFill>
+                  <a:srgbClr val="1A1F2B"/>
+                </a:solidFill>
+                <a:latin typeface="Microsoft YaHei"/>
+                <a:ea typeface="Microsoft YaHei"/>
+                <a:cs typeface="Microsoft YaHei"/>
+              </a:rPr>
+              <a:t>[7]  图 2.1 Intel Core i9-13900K die shot — Fritzchens Fritz / JmsDoug, CC0, Wikimedia Commons.</a:t>
+            </a:r>
+          </a:p>
+          <a:p>
+            <a:pPr algn="l">
+              <a:lnSpc>
+                <a:spcPct val="118000"/>
+              </a:lnSpc>
+              <a:spcAft>
+                <a:spcPts val="800"/>
+              </a:spcAft>
+            </a:pPr>
+            <a:r>
+              <a:rPr sz="1200" b="0">
+                <a:solidFill>
+                  <a:srgbClr val="1A1F2B"/>
+                </a:solidFill>
+                <a:latin typeface="Microsoft YaHei"/>
+                <a:ea typeface="Microsoft YaHei"/>
+                <a:cs typeface="Microsoft YaHei"/>
+              </a:rPr>
+              <a:t>[8]  图 3.3 Wire-bonding close-up — Mister rf, CC BY-SA 4.0, Wikimedia Commons.</a:t>
+            </a:r>
+          </a:p>
+          <a:p>
+            <a:pPr algn="l">
+              <a:lnSpc>
+                <a:spcPct val="118000"/>
+              </a:lnSpc>
+              <a:spcAft>
+                <a:spcPts val="800"/>
+              </a:spcAft>
+            </a:pPr>
+            <a:r>
+              <a:rPr sz="1200" b="0">
+                <a:solidFill>
+                  <a:srgbClr val="1A1F2B"/>
+                </a:solidFill>
+                <a:latin typeface="Microsoft YaHei"/>
+                <a:ea typeface="Microsoft YaHei"/>
+                <a:cs typeface="Microsoft YaHei"/>
+              </a:rPr>
+              <a:t>[9]  图 4.1 Bitfury 顶层金属供电网 — ZeptoBars, CC BY 3.0, Wikimedia Commons.</a:t>
+            </a:r>
+          </a:p>
+          <a:p>
+            <a:pPr algn="l">
+              <a:lnSpc>
+                <a:spcPct val="118000"/>
+              </a:lnSpc>
+              <a:spcAft>
+                <a:spcPts val="800"/>
+              </a:spcAft>
+            </a:pPr>
+            <a:r>
+              <a:rPr sz="1200" b="0">
+                <a:solidFill>
+                  <a:srgbClr val="1A1F2B"/>
+                </a:solidFill>
+                <a:latin typeface="Microsoft YaHei"/>
+                <a:ea typeface="Microsoft YaHei"/>
+                <a:cs typeface="Microsoft YaHei"/>
+              </a:rPr>
+              <a:t>[10]  图 4.2 Static IR-drop map — Seo et al. (WACA-UNet), arXiv:2507.19197, CC BY 4.0.</a:t>
+            </a:r>
+          </a:p>
+        </p:txBody>
+      </p:sp>
+      <p:sp>
+        <p:nvSpPr>
+          <p:cNvPr id="7" name="TextBox 6"/>
           <p:cNvSpPr txBox="1"/>
           <p:nvPr/>
         </p:nvSpPr>
@@ -17095,7 +17240,7 @@
           <a:lstStyle/>
           <a:p>
             <a:pPr algn="r"/>
-            <a:fld id="{757DA1F4-3B43-496C-96F5-AB9D7B547792}" type="slidenum">
+            <a:fld id="{B8A48CF9-80C1-403A-8FA5-6494CD0EE803}" type="slidenum">
               <a:rPr lang="en-US" sz="1000">
                 <a:solidFill>
                   <a:srgbClr val="9AA3B0"/>
@@ -17298,7 +17443,7 @@
                 <a:ea typeface="Microsoft YaHei"/>
                 <a:cs typeface="Microsoft YaHei"/>
               </a:rPr>
-              <a:t>下一讲：Placement 标准单元布局（DVD Lecture 7）</a:t>
+              <a:t>下一讲：Placement 标准单元布局</a:t>
             </a:r>
           </a:p>
         </p:txBody>
@@ -17424,7 +17569,7 @@
                 <a:ea typeface="Microsoft YaHei"/>
                 <a:cs typeface="Microsoft YaHei"/>
               </a:rPr>
-              <a:t>整理 J.C  ·  源自 Digital VLSI Design (DVD), Prof. Adam Teman, Bar-Ilan University (83-612)</a:t>
+              <a:t>整理 J.C</a:t>
             </a:r>
           </a:p>
         </p:txBody>
@@ -17578,8 +17723,8 @@
         </p:nvSpPr>
         <p:spPr>
           <a:xfrm>
-            <a:off x="640080" y="1600200"/>
-            <a:ext cx="10972800" cy="4846320"/>
+            <a:off x="640080" y="1572768"/>
+            <a:ext cx="4754880" cy="4937760"/>
           </a:xfrm>
           <a:prstGeom prst="rect">
             <a:avLst/>
@@ -17594,14 +17739,14 @@
           <a:p>
             <a:pPr algn="l">
               <a:lnSpc>
-                <a:spcPct val="125000"/>
+                <a:spcPct val="116000"/>
               </a:lnSpc>
               <a:spcAft>
-                <a:spcPts val="1000"/>
-              </a:spcAft>
-            </a:pPr>
-            <a:r>
-              <a:rPr sz="1500" b="0">
+                <a:spcPts val="800"/>
+              </a:spcAft>
+            </a:pPr>
+            <a:r>
+              <a:rPr sz="1400" b="0">
                 <a:solidFill>
                   <a:srgbClr val="1A1F2B"/>
                 </a:solidFill>
@@ -17615,14 +17760,14 @@
           <a:p>
             <a:pPr algn="l">
               <a:lnSpc>
-                <a:spcPct val="125000"/>
+                <a:spcPct val="116000"/>
               </a:lnSpc>
               <a:spcAft>
-                <a:spcPts val="1000"/>
-              </a:spcAft>
-            </a:pPr>
-            <a:r>
-              <a:rPr sz="1500" b="0">
+                <a:spcPts val="800"/>
+              </a:spcAft>
+            </a:pPr>
+            <a:r>
+              <a:rPr sz="1400" b="0">
                 <a:solidFill>
                   <a:srgbClr val="1A1F2B"/>
                 </a:solidFill>
@@ -17630,20 +17775,20 @@
                 <a:ea typeface="Microsoft YaHei"/>
                 <a:cs typeface="Microsoft YaHei"/>
               </a:rPr>
-              <a:t>▪  Floorplan 把这张逻辑网表落成可实现的物理骨架，是从逻辑世界进入物理世界的第一层承诺</a:t>
+              <a:t>▪  Floorplan 把它落成可实现的物理骨架——从逻辑世界进入物理世界的第一层承诺</a:t>
             </a:r>
           </a:p>
           <a:p>
             <a:pPr algn="l">
               <a:lnSpc>
-                <a:spcPct val="125000"/>
+                <a:spcPct val="116000"/>
               </a:lnSpc>
               <a:spcAft>
-                <a:spcPts val="1000"/>
-              </a:spcAft>
-            </a:pPr>
-            <a:r>
-              <a:rPr sz="1500" b="0">
+                <a:spcPts val="800"/>
+              </a:spcAft>
+            </a:pPr>
+            <a:r>
+              <a:rPr sz="1400" b="0">
                 <a:solidFill>
                   <a:srgbClr val="1A1F2B"/>
                 </a:solidFill>
@@ -17651,20 +17796,20 @@
                 <a:ea typeface="Microsoft YaHei"/>
                 <a:cs typeface="Microsoft YaHei"/>
               </a:rPr>
-              <a:t>▪  骨架至少包括：晶粒 die 边界与核心区 core，IO / 焊盘 / 凸点的大致位置</a:t>
+              <a:t>▪  骨架含：晶粒 die / 核心区 core，IO / 焊盘 / 凸点的大致位置</a:t>
             </a:r>
           </a:p>
           <a:p>
             <a:pPr algn="l">
               <a:lnSpc>
-                <a:spcPct val="125000"/>
+                <a:spcPct val="116000"/>
               </a:lnSpc>
               <a:spcAft>
-                <a:spcPts val="1000"/>
-              </a:spcAft>
-            </a:pPr>
-            <a:r>
-              <a:rPr sz="1500" b="0">
+                <a:spcPts val="800"/>
+              </a:spcAft>
+            </a:pPr>
+            <a:r>
+              <a:rPr sz="1400" b="0">
                 <a:solidFill>
                   <a:srgbClr val="1A1F2B"/>
                 </a:solidFill>
@@ -17678,14 +17823,14 @@
           <a:p>
             <a:pPr algn="l">
               <a:lnSpc>
-                <a:spcPct val="125000"/>
+                <a:spcPct val="116000"/>
               </a:lnSpc>
               <a:spcAft>
-                <a:spcPts val="1000"/>
-              </a:spcAft>
-            </a:pPr>
-            <a:r>
-              <a:rPr sz="1500" b="0">
+                <a:spcPts val="800"/>
+              </a:spcAft>
+            </a:pPr>
+            <a:r>
+              <a:rPr sz="1400" b="0">
                 <a:solidFill>
                   <a:srgbClr val="1A1F2B"/>
                 </a:solidFill>
@@ -17693,20 +17838,20 @@
                 <a:ea typeface="Microsoft YaHei"/>
                 <a:cs typeface="Microsoft YaHei"/>
               </a:rPr>
-              <a:t>▪  电源环 / 条带 / 网格 / 供电轨，以及阻挡 / 留边 / 区域约束等物理约束</a:t>
+              <a:t>▪  电源环 / 条带 / 网格 / 供电轨，阻挡 / 留边 / 区域约束等物理约束</a:t>
             </a:r>
           </a:p>
           <a:p>
             <a:pPr algn="l">
               <a:lnSpc>
-                <a:spcPct val="125000"/>
+                <a:spcPct val="116000"/>
               </a:lnSpc>
               <a:spcAft>
-                <a:spcPts val="1000"/>
-              </a:spcAft>
-            </a:pPr>
-            <a:r>
-              <a:rPr sz="1500" b="0">
+                <a:spcPts val="800"/>
+              </a:spcAft>
+            </a:pPr>
+            <a:r>
+              <a:rPr sz="1400" b="0">
                 <a:solidFill>
                   <a:srgbClr val="1A1F2B"/>
                 </a:solidFill>
@@ -17714,35 +17859,79 @@
                 <a:ea typeface="Microsoft YaHei"/>
                 <a:cs typeface="Microsoft YaHei"/>
               </a:rPr>
-              <a:t>▪  后续布局、CTS、布线与电源签核都沿这个骨架继续细化</a:t>
-            </a:r>
-          </a:p>
-          <a:p>
-            <a:pPr algn="l">
-              <a:lnSpc>
-                <a:spcPct val="125000"/>
-              </a:lnSpc>
-              <a:spcAft>
-                <a:spcPts val="1000"/>
-              </a:spcAft>
-            </a:pPr>
-            <a:r>
-              <a:rPr sz="1500" b="0">
-                <a:solidFill>
-                  <a:srgbClr val="1A1F2B"/>
-                </a:solidFill>
-                <a:latin typeface="Microsoft YaHei"/>
-                <a:ea typeface="Microsoft YaHei"/>
-                <a:cs typeface="Microsoft YaHei"/>
-              </a:rPr>
-              <a:t>▪  此阶段改动成本低，签核阶段再改则可能牵一发而动全身</a:t>
-            </a:r>
-          </a:p>
-        </p:txBody>
-      </p:sp>
-      <p:sp>
-        <p:nvSpPr>
-          <p:cNvPr id="6" name="TextBox 5"/>
+              <a:t>▪  下游布局 / CTS / 布线 / 签核都沿此骨架细化；此阶段改成本低，签核再改则牵一发而动全身</a:t>
+            </a:r>
+          </a:p>
+        </p:txBody>
+      </p:sp>
+      <p:pic>
+        <p:nvPicPr>
+          <p:cNvPr id="6" name="Picture 5" descr="ext_die_486_ccby.jpg"/>
+          <p:cNvPicPr>
+            <a:picLocks noChangeAspect="1"/>
+          </p:cNvPicPr>
+          <p:nvPr/>
+        </p:nvPicPr>
+        <p:blipFill>
+          <a:blip r:embed="rId2"/>
+          <a:stretch>
+            <a:fillRect/>
+          </a:stretch>
+        </p:blipFill>
+        <p:spPr>
+          <a:xfrm>
+            <a:off x="5486400" y="2125797"/>
+            <a:ext cx="6263640" cy="3657965"/>
+          </a:xfrm>
+          <a:prstGeom prst="rect">
+            <a:avLst/>
+          </a:prstGeom>
+        </p:spPr>
+      </p:pic>
+      <p:sp>
+        <p:nvSpPr>
+          <p:cNvPr id="7" name="TextBox 6"/>
+          <p:cNvSpPr txBox="1"/>
+          <p:nvPr/>
+        </p:nvSpPr>
+        <p:spPr>
+          <a:xfrm>
+            <a:off x="5486400" y="6382512"/>
+            <a:ext cx="6263640" cy="274320"/>
+          </a:xfrm>
+          <a:prstGeom prst="rect">
+            <a:avLst/>
+          </a:prstGeom>
+          <a:noFill/>
+        </p:spPr>
+        <p:txBody>
+          <a:bodyPr wrap="square" anchor="t" lIns="25400" rIns="25400" tIns="25400" bIns="25400">
+            <a:spAutoFit/>
+          </a:bodyPr>
+          <a:lstStyle/>
+          <a:p>
+            <a:pPr algn="r">
+              <a:spcAft>
+                <a:spcPts val="600"/>
+              </a:spcAft>
+            </a:pPr>
+            <a:r>
+              <a:rPr sz="900" b="0">
+                <a:solidFill>
+                  <a:srgbClr val="6B7280"/>
+                </a:solidFill>
+                <a:latin typeface="Microsoft YaHei"/>
+                <a:ea typeface="Microsoft YaHei"/>
+                <a:cs typeface="Microsoft YaHei"/>
+              </a:rPr>
+              <a:t>来源：Intel 80486DX2 die（功能块标注）· Smial · CC BY 3.0 · Wikimedia</a:t>
+            </a:r>
+          </a:p>
+        </p:txBody>
+      </p:sp>
+      <p:sp>
+        <p:nvSpPr>
+          <p:cNvPr id="8" name="TextBox 7"/>
           <p:cNvSpPr txBox="1"/>
           <p:nvPr/>
         </p:nvSpPr>
@@ -17763,7 +17952,7 @@
           <a:lstStyle/>
           <a:p>
             <a:pPr algn="r"/>
-            <a:fld id="{F21CFACB-7354-4239-817B-B0520FDEABBB}" type="slidenum">
+            <a:fld id="{BD9210C9-080A-4EE7-B132-1F339F407D8A}" type="slidenum">
               <a:rPr lang="en-US" sz="1000">
                 <a:solidFill>
                   <a:srgbClr val="9AA3B0"/>
@@ -18425,7 +18614,7 @@
           <a:lstStyle/>
           <a:p>
             <a:pPr algn="r"/>
-            <a:fld id="{1652741C-7F6F-4B73-93CB-B5B9C1DC9DA0}" type="slidenum">
+            <a:fld id="{33E3DE75-8222-4E2F-9183-60B209580E96}" type="slidenum">
               <a:rPr lang="en-US" sz="1000">
                 <a:solidFill>
                   <a:srgbClr val="9AA3B0"/>
@@ -18617,7 +18806,7 @@
                 <a:ea typeface="Microsoft YaHei"/>
                 <a:cs typeface="Microsoft YaHei"/>
               </a:rPr>
-              <a:t>①  映射：netlist（谁连谁）→ floorplan（谁放哪、怎么连、怎么供电）</a:t>
+              <a:t>Floorplan 本质是一个映射：把“谁连谁”的逻辑网表，落成实例、IO、宏单元与电源网络在芯片上如何摆放、连接与供电。</a:t>
             </a:r>
           </a:p>
           <a:p>
@@ -18638,7 +18827,7 @@
                 <a:ea typeface="Microsoft YaHei"/>
                 <a:cs typeface="Microsoft YaHei"/>
               </a:rPr>
-              <a:t>②  同时服务三个目标：减小芯片面积</a:t>
+              <a:t>它要同时服务三个目标——减小芯片面积、减小关键路径延迟、减小布线拥塞。</a:t>
             </a:r>
           </a:p>
           <a:p>
@@ -18659,7 +18848,7 @@
                 <a:ea typeface="Microsoft YaHei"/>
                 <a:cs typeface="Microsoft YaHei"/>
               </a:rPr>
-              <a:t>③  减小关键路径延迟</a:t>
+              <a:t>但三者天然冲突：面积压太紧会拥塞，通道留太宽会浪费面积，电源网格做太强又抢走信号布线资源。</a:t>
             </a:r>
           </a:p>
           <a:p>
@@ -18680,49 +18869,7 @@
                 <a:ea typeface="Microsoft YaHei"/>
                 <a:cs typeface="Microsoft YaHei"/>
               </a:rPr>
-              <a:t>④  减小布线拥塞</a:t>
-            </a:r>
-          </a:p>
-          <a:p>
-            <a:pPr algn="l">
-              <a:lnSpc>
-                <a:spcPct val="116000"/>
-              </a:lnSpc>
-              <a:spcAft>
-                <a:spcPts val="800"/>
-              </a:spcAft>
-            </a:pPr>
-            <a:r>
-              <a:rPr sz="1400" b="0">
-                <a:solidFill>
-                  <a:srgbClr val="1A1F2B"/>
-                </a:solidFill>
-                <a:latin typeface="Microsoft YaHei"/>
-                <a:ea typeface="Microsoft YaHei"/>
-                <a:cs typeface="Microsoft YaHei"/>
-              </a:rPr>
-              <a:t>⑤  三者天然冲突：压面积→拥塞，留宽通道→浪费，强网格→抢信号</a:t>
-            </a:r>
-          </a:p>
-          <a:p>
-            <a:pPr algn="l">
-              <a:lnSpc>
-                <a:spcPct val="116000"/>
-              </a:lnSpc>
-              <a:spcAft>
-                <a:spcPts val="800"/>
-              </a:spcAft>
-            </a:pPr>
-            <a:r>
-              <a:rPr sz="1400" b="0">
-                <a:solidFill>
-                  <a:srgbClr val="1A1F2B"/>
-                </a:solidFill>
-                <a:latin typeface="Microsoft YaHei"/>
-                <a:ea typeface="Microsoft YaHei"/>
-                <a:cs typeface="Microsoft YaHei"/>
-              </a:rPr>
-              <a:t>⑥  因此是面积/时序/拥塞/供电的第一轮工程取舍</a:t>
+              <a:t>因此 Floorplan 是在面积、时序、拥塞与供电可靠性之间做的第一轮工程取舍。</a:t>
             </a:r>
           </a:p>
         </p:txBody>
@@ -19573,7 +19720,7 @@
           <a:lstStyle/>
           <a:p>
             <a:pPr algn="r"/>
-            <a:fld id="{9EE8ABDC-9FF7-4FC8-A1A3-3ACCCF2E6C1B}" type="slidenum">
+            <a:fld id="{EC0696B9-B25B-4DFF-8610-A627F29C962A}" type="slidenum">
               <a:rPr lang="en-US" sz="1000">
                 <a:solidFill>
                   <a:srgbClr val="9AA3B0"/>
@@ -20603,7 +20750,7 @@
           <a:lstStyle/>
           <a:p>
             <a:pPr algn="r"/>
-            <a:fld id="{C010EE06-19D0-407C-89CC-D97F0475598F}" type="slidenum">
+            <a:fld id="{7AC00E5B-DDA4-4599-A00E-328CDD540C76}" type="slidenum">
               <a:rPr lang="en-US" sz="1000">
                 <a:solidFill>
                   <a:srgbClr val="9AA3B0"/>
@@ -21680,7 +21827,7 @@
           <a:lstStyle/>
           <a:p>
             <a:pPr algn="r"/>
-            <a:fld id="{D58063B6-B2B4-4C1B-B8C0-479E0D300BBF}" type="slidenum">
+            <a:fld id="{07B92D92-06B8-4F6E-B094-BAC4AE3A21E6}" type="slidenum">
               <a:rPr lang="en-US" sz="1000">
                 <a:solidFill>
                   <a:srgbClr val="9AA3B0"/>

</xml_diff>

<commit_message>
deck: expand to 2-3 OA figures per pictorial slide (18 figs) + replace last drawn schematics
Added second/third openly-licensed figures: 1.1 +wafer; 2.2 +real-layout congestion heatmap (vstack); 2.4 +SRAM-array die (3-up); 3.2 +PD-flow (vstack); 3.3 +open-package photo; 4.3 bl->split +2 real EM SEM photos. Replaced last drawn schematics with verified OA: 2.6 FloorSet placement-constraints (CC BY 4.0), 4.7 CFIRSTNET IR-on-layout hotspot (CC BY 4.0). New deck: figs_v vertical-stack for wide figures. Image Credits page consolidated per-slide with DOIs. All 18 figures license-verified on source page (CC0/CC-BY/CC-BY-SA), captioned + credited. Only 4.1 keeps Bitfury single (no 2nd OA PDN figure found).

Co-Authored-By: Claude Opus 4.8 <noreply@anthropic.com>
</commit_message>
<xml_diff>
--- a/IC_Backend_Notes/slides/05_Floorplan - 副本.pptx
+++ b/IC_Backend_Notes/slides/05_Floorplan - 副本.pptx
@@ -39,6 +39,7 @@
     <p:sldId id="287" r:id="rId38"/>
     <p:sldId id="288" r:id="rId39"/>
     <p:sldId id="289" r:id="rId40"/>
+    <p:sldId id="290" r:id="rId41"/>
   </p:sldIdLst>
   <p:sldSz cx="12191695" cy="6858000" type="screen4x3"/>
   <p:notesSz cx="6858000" cy="9144000"/>
@@ -1199,7 +1200,7 @@
         </p:nvSpPr>
         <p:spPr>
           <a:xfrm>
-            <a:off x="5486400" y="6382512"/>
+            <a:off x="5486400" y="6272784"/>
             <a:ext cx="6263640" cy="274320"/>
           </a:xfrm>
           <a:prstGeom prst="rect">
@@ -1255,7 +1256,7 @@
           <a:lstStyle/>
           <a:p>
             <a:pPr algn="r"/>
-            <a:fld id="{8D9AC73B-3779-41B9-B05A-0292D943A81B}" type="slidenum">
+            <a:fld id="{767CFF2D-835B-4889-B76B-2E19EEE6D0C4}" type="slidenum">
               <a:rPr lang="en-US" sz="1000">
                 <a:solidFill>
                   <a:srgbClr val="9AA3B0"/>
@@ -1496,7 +1497,7 @@
       </p:sp>
       <p:pic>
         <p:nvPicPr>
-          <p:cNvPr id="6" name="Picture 5" descr="f04_util.png"/>
+          <p:cNvPr id="6" name="Picture 5" descr="ext_congest_verihgn_ccby.png"/>
           <p:cNvPicPr>
             <a:picLocks noChangeAspect="1"/>
           </p:cNvPicPr>
@@ -1510,8 +1511,8 @@
         </p:blipFill>
         <p:spPr>
           <a:xfrm>
-            <a:off x="5486400" y="1575143"/>
-            <a:ext cx="6263640" cy="4759272"/>
+            <a:off x="5486400" y="2455590"/>
+            <a:ext cx="6263640" cy="2358298"/>
           </a:xfrm>
           <a:prstGeom prst="rect">
             <a:avLst/>
@@ -1521,6 +1522,88 @@
       <p:sp>
         <p:nvSpPr>
           <p:cNvPr id="7" name="TextBox 6"/>
+          <p:cNvSpPr txBox="1"/>
+          <p:nvPr/>
+        </p:nvSpPr>
+        <p:spPr>
+          <a:xfrm>
+            <a:off x="5486400" y="5797296"/>
+            <a:ext cx="6263640" cy="457200"/>
+          </a:xfrm>
+          <a:prstGeom prst="rect">
+            <a:avLst/>
+          </a:prstGeom>
+          <a:noFill/>
+        </p:spPr>
+        <p:txBody>
+          <a:bodyPr wrap="square" anchor="t" lIns="25400" rIns="25400" tIns="25400" bIns="25400">
+            <a:spAutoFit/>
+          </a:bodyPr>
+          <a:lstStyle/>
+          <a:p>
+            <a:pPr algn="ctr">
+              <a:spcAft>
+                <a:spcPts val="600"/>
+              </a:spcAft>
+            </a:pPr>
+            <a:r>
+              <a:rPr sz="1200" b="0">
+                <a:solidFill>
+                  <a:srgbClr val="6B7280"/>
+                </a:solidFill>
+                <a:latin typeface="Microsoft YaHei"/>
+                <a:ea typeface="Microsoft YaHei"/>
+                <a:cs typeface="Microsoft YaHei"/>
+              </a:rPr>
+              <a:t>图 1 · 拥塞如何形成：逻辑块 → 布线竞争 → 拥塞热力图</a:t>
+            </a:r>
+          </a:p>
+        </p:txBody>
+      </p:sp>
+      <p:sp>
+        <p:nvSpPr>
+          <p:cNvPr id="8" name="TextBox 7"/>
+          <p:cNvSpPr txBox="1"/>
+          <p:nvPr/>
+        </p:nvSpPr>
+        <p:spPr>
+          <a:xfrm>
+            <a:off x="5486400" y="6272784"/>
+            <a:ext cx="6263640" cy="274320"/>
+          </a:xfrm>
+          <a:prstGeom prst="rect">
+            <a:avLst/>
+          </a:prstGeom>
+          <a:noFill/>
+        </p:spPr>
+        <p:txBody>
+          <a:bodyPr wrap="square" anchor="t" lIns="25400" rIns="25400" tIns="25400" bIns="25400">
+            <a:spAutoFit/>
+          </a:bodyPr>
+          <a:lstStyle/>
+          <a:p>
+            <a:pPr algn="r">
+              <a:spcAft>
+                <a:spcPts val="600"/>
+              </a:spcAft>
+            </a:pPr>
+            <a:r>
+              <a:rPr sz="900" b="0">
+                <a:solidFill>
+                  <a:srgbClr val="6B7280"/>
+                </a:solidFill>
+                <a:latin typeface="Microsoft YaHei"/>
+                <a:ea typeface="Microsoft YaHei"/>
+                <a:cs typeface="Microsoft YaHei"/>
+              </a:rPr>
+              <a:t>来源：VeriHGN, Hu et al. · arXiv:2603.11075 · CC BY 4.0</a:t>
+            </a:r>
+          </a:p>
+        </p:txBody>
+      </p:sp>
+      <p:sp>
+        <p:nvSpPr>
+          <p:cNvPr id="9" name="TextBox 8"/>
           <p:cNvSpPr txBox="1"/>
           <p:nvPr/>
         </p:nvSpPr>
@@ -1541,7 +1624,7 @@
           <a:lstStyle/>
           <a:p>
             <a:pPr algn="r"/>
-            <a:fld id="{D6B2CC82-306B-4FD9-8693-34F425358B28}" type="slidenum">
+            <a:fld id="{DEB5BB32-962B-4F5C-89DB-29686B8CF750}" type="slidenum">
               <a:rPr lang="en-US" sz="1000">
                 <a:solidFill>
                   <a:srgbClr val="9AA3B0"/>
@@ -3066,7 +3149,7 @@
           <a:lstStyle/>
           <a:p>
             <a:pPr algn="r"/>
-            <a:fld id="{FD2171DB-AC36-4510-AA79-B02E6FE434E5}" type="slidenum">
+            <a:fld id="{B6C1064D-1F40-4660-9DC7-8344A1A1D645}" type="slidenum">
               <a:rPr lang="en-US" sz="1000">
                 <a:solidFill>
                   <a:srgbClr val="9AA3B0"/>
@@ -3370,7 +3453,7 @@
       </p:sp>
       <p:pic>
         <p:nvPicPr>
-          <p:cNvPr id="6" name="Picture 5" descr="f06_macro.png"/>
+          <p:cNvPr id="6" name="Picture 5" descr="ext_die_ultrasparc_ccbysa.jpg"/>
           <p:cNvPicPr>
             <a:picLocks noChangeAspect="1"/>
           </p:cNvPicPr>
@@ -3384,8 +3467,8 @@
         </p:blipFill>
         <p:spPr>
           <a:xfrm>
-            <a:off x="5486400" y="1676348"/>
-            <a:ext cx="6263640" cy="4556863"/>
+            <a:off x="5486400" y="1638049"/>
+            <a:ext cx="3031236" cy="3216141"/>
           </a:xfrm>
           <a:prstGeom prst="rect">
             <a:avLst/>
@@ -3395,6 +3478,194 @@
       <p:sp>
         <p:nvSpPr>
           <p:cNvPr id="7" name="TextBox 6"/>
+          <p:cNvSpPr txBox="1"/>
+          <p:nvPr/>
+        </p:nvSpPr>
+        <p:spPr>
+          <a:xfrm>
+            <a:off x="5486400" y="5010912"/>
+            <a:ext cx="3031236" cy="566928"/>
+          </a:xfrm>
+          <a:prstGeom prst="rect">
+            <a:avLst/>
+          </a:prstGeom>
+          <a:noFill/>
+        </p:spPr>
+        <p:txBody>
+          <a:bodyPr wrap="square" anchor="t" lIns="25400" rIns="25400" tIns="25400" bIns="25400">
+            <a:spAutoFit/>
+          </a:bodyPr>
+          <a:lstStyle/>
+          <a:p>
+            <a:pPr algn="ctr">
+              <a:spcAft>
+                <a:spcPts val="600"/>
+              </a:spcAft>
+            </a:pPr>
+            <a:r>
+              <a:rPr sz="1000" b="0">
+                <a:solidFill>
+                  <a:srgbClr val="6B7280"/>
+                </a:solidFill>
+                <a:latin typeface="Microsoft YaHei"/>
+                <a:ea typeface="Microsoft YaHei"/>
+                <a:cs typeface="Microsoft YaHei"/>
+              </a:rPr>
+              <a:t>图 2 · 真实 die：8 核 + L2 缓存等存储宏沿核区分布</a:t>
+            </a:r>
+          </a:p>
+        </p:txBody>
+      </p:sp>
+      <p:sp>
+        <p:nvSpPr>
+          <p:cNvPr id="8" name="TextBox 7"/>
+          <p:cNvSpPr txBox="1"/>
+          <p:nvPr/>
+        </p:nvSpPr>
+        <p:spPr>
+          <a:xfrm>
+            <a:off x="5486400" y="5559552"/>
+            <a:ext cx="3031236" cy="274320"/>
+          </a:xfrm>
+          <a:prstGeom prst="rect">
+            <a:avLst/>
+          </a:prstGeom>
+          <a:noFill/>
+        </p:spPr>
+        <p:txBody>
+          <a:bodyPr wrap="square" anchor="t" lIns="25400" rIns="25400" tIns="25400" bIns="25400">
+            <a:spAutoFit/>
+          </a:bodyPr>
+          <a:lstStyle/>
+          <a:p>
+            <a:pPr algn="ctr">
+              <a:spcAft>
+                <a:spcPts val="600"/>
+              </a:spcAft>
+            </a:pPr>
+            <a:r>
+              <a:rPr sz="800" b="0">
+                <a:solidFill>
+                  <a:srgbClr val="6B7280"/>
+                </a:solidFill>
+                <a:latin typeface="Microsoft YaHei"/>
+                <a:ea typeface="Microsoft YaHei"/>
+                <a:cs typeface="Microsoft YaHei"/>
+              </a:rPr>
+              <a:t>来源：UltraSPARC T1 · ZyMOS / Fritzchens Fritz · CC BY-SA 3.0</a:t>
+            </a:r>
+          </a:p>
+        </p:txBody>
+      </p:sp>
+      <p:pic>
+        <p:nvPicPr>
+          <p:cNvPr id="9" name="Picture 8" descr="ext_floorplan_compare_ccbysa.png"/>
+          <p:cNvPicPr>
+            <a:picLocks noChangeAspect="1"/>
+          </p:cNvPicPr>
+          <p:nvPr/>
+        </p:nvPicPr>
+        <p:blipFill>
+          <a:blip r:embed="rId3"/>
+          <a:stretch>
+            <a:fillRect/>
+          </a:stretch>
+        </p:blipFill>
+        <p:spPr>
+          <a:xfrm>
+            <a:off x="8718804" y="2230531"/>
+            <a:ext cx="3031236" cy="2031176"/>
+          </a:xfrm>
+          <a:prstGeom prst="rect">
+            <a:avLst/>
+          </a:prstGeom>
+        </p:spPr>
+      </p:pic>
+      <p:sp>
+        <p:nvSpPr>
+          <p:cNvPr id="10" name="TextBox 9"/>
+          <p:cNvSpPr txBox="1"/>
+          <p:nvPr/>
+        </p:nvSpPr>
+        <p:spPr>
+          <a:xfrm>
+            <a:off x="8718804" y="5010912"/>
+            <a:ext cx="3031236" cy="566928"/>
+          </a:xfrm>
+          <a:prstGeom prst="rect">
+            <a:avLst/>
+          </a:prstGeom>
+          <a:noFill/>
+        </p:spPr>
+        <p:txBody>
+          <a:bodyPr wrap="square" anchor="t" lIns="25400" rIns="25400" tIns="25400" bIns="25400">
+            <a:spAutoFit/>
+          </a:bodyPr>
+          <a:lstStyle/>
+          <a:p>
+            <a:pPr algn="ctr">
+              <a:spcAft>
+                <a:spcPts val="600"/>
+              </a:spcAft>
+            </a:pPr>
+            <a:r>
+              <a:rPr sz="1000" b="0">
+                <a:solidFill>
+                  <a:srgbClr val="6B7280"/>
+                </a:solidFill>
+                <a:latin typeface="Microsoft YaHei"/>
+                <a:ea typeface="Microsoft YaHei"/>
+                <a:cs typeface="Microsoft YaHei"/>
+              </a:rPr>
+              <a:t>图 3 · 宏摆放对比：人工分区 vs 规则 AI</a:t>
+            </a:r>
+          </a:p>
+        </p:txBody>
+      </p:sp>
+      <p:sp>
+        <p:nvSpPr>
+          <p:cNvPr id="11" name="TextBox 10"/>
+          <p:cNvSpPr txBox="1"/>
+          <p:nvPr/>
+        </p:nvSpPr>
+        <p:spPr>
+          <a:xfrm>
+            <a:off x="8718804" y="5559552"/>
+            <a:ext cx="3031236" cy="274320"/>
+          </a:xfrm>
+          <a:prstGeom prst="rect">
+            <a:avLst/>
+          </a:prstGeom>
+          <a:noFill/>
+        </p:spPr>
+        <p:txBody>
+          <a:bodyPr wrap="square" anchor="t" lIns="25400" rIns="25400" tIns="25400" bIns="25400">
+            <a:spAutoFit/>
+          </a:bodyPr>
+          <a:lstStyle/>
+          <a:p>
+            <a:pPr algn="ctr">
+              <a:spcAft>
+                <a:spcPts val="600"/>
+              </a:spcAft>
+            </a:pPr>
+            <a:r>
+              <a:rPr sz="800" b="0">
+                <a:solidFill>
+                  <a:srgbClr val="6B7280"/>
+                </a:solidFill>
+                <a:latin typeface="Microsoft YaHei"/>
+                <a:ea typeface="Microsoft YaHei"/>
+                <a:cs typeface="Microsoft YaHei"/>
+              </a:rPr>
+              <a:t>来源：Copparihollmann · CC BY-SA 4.0 · Wikimedia</a:t>
+            </a:r>
+          </a:p>
+        </p:txBody>
+      </p:sp>
+      <p:sp>
+        <p:nvSpPr>
+          <p:cNvPr id="12" name="TextBox 11"/>
           <p:cNvSpPr txBox="1"/>
           <p:nvPr/>
         </p:nvSpPr>
@@ -3415,7 +3686,7 @@
           <a:lstStyle/>
           <a:p>
             <a:pPr algn="r"/>
-            <a:fld id="{C1FAE399-EE9E-47EC-B57F-6FDC0EDD29F5}" type="slidenum">
+            <a:fld id="{2CA07AAC-6147-473C-B8DC-84DC64767F1E}" type="slidenum">
               <a:rPr lang="en-US" sz="1000">
                 <a:solidFill>
                   <a:srgbClr val="9AA3B0"/>
@@ -4303,7 +4574,7 @@
           <a:lstStyle/>
           <a:p>
             <a:pPr algn="r"/>
-            <a:fld id="{6D3C1CDF-E65E-4021-BBAB-0C88A51DF74A}" type="slidenum">
+            <a:fld id="{B5F38169-66AD-4AA5-9883-1459A345CD46}" type="slidenum">
               <a:rPr lang="en-US" sz="1000">
                 <a:solidFill>
                   <a:srgbClr val="9AA3B0"/>
@@ -4652,7 +4923,7 @@
           <a:lstStyle/>
           <a:p>
             <a:pPr algn="r"/>
-            <a:fld id="{06C38842-2BB9-40E0-A19C-BE6EBD0719C6}" type="slidenum">
+            <a:fld id="{AF50E6D6-586A-49AD-96CB-EED420F0A00C}" type="slidenum">
               <a:rPr lang="en-US" sz="1000">
                 <a:solidFill>
                   <a:srgbClr val="9AA3B0"/>
@@ -5021,7 +5292,7 @@
           <a:lstStyle/>
           <a:p>
             <a:pPr algn="r"/>
-            <a:fld id="{821460AE-D0F9-4173-A2B6-D0E6EFFD972D}" type="slidenum">
+            <a:fld id="{DD5CF2FB-2F49-4D10-944E-4FF015390A45}" type="slidenum">
               <a:rPr lang="en-US" sz="1000">
                 <a:solidFill>
                   <a:srgbClr val="9AA3B0"/>
@@ -6742,7 +7013,7 @@
           <a:lstStyle/>
           <a:p>
             <a:pPr algn="r"/>
-            <a:fld id="{19DDB01F-B288-4A2D-A5C3-2A7690D1F795}" type="slidenum">
+            <a:fld id="{529F632F-1A20-41AB-9284-9B68C057B491}" type="slidenum">
               <a:rPr lang="en-US" sz="1000">
                 <a:solidFill>
                   <a:srgbClr val="9AA3B0"/>
@@ -6983,7 +7254,7 @@
       </p:sp>
       <p:pic>
         <p:nvPicPr>
-          <p:cNvPr id="6" name="Picture 5" descr="f11_budget.png"/>
+          <p:cNvPr id="6" name="Picture 5" descr="ext_block_floorplan_parsac_ccbysa.png"/>
           <p:cNvPicPr>
             <a:picLocks noChangeAspect="1"/>
           </p:cNvPicPr>
@@ -6997,8 +7268,8 @@
         </p:blipFill>
         <p:spPr>
           <a:xfrm>
-            <a:off x="5486400" y="1711904"/>
-            <a:ext cx="6263640" cy="4485750"/>
+            <a:off x="5486400" y="2068830"/>
+            <a:ext cx="6263640" cy="3131820"/>
           </a:xfrm>
           <a:prstGeom prst="rect">
             <a:avLst/>
@@ -7008,6 +7279,88 @@
       <p:sp>
         <p:nvSpPr>
           <p:cNvPr id="7" name="TextBox 6"/>
+          <p:cNvSpPr txBox="1"/>
+          <p:nvPr/>
+        </p:nvSpPr>
+        <p:spPr>
+          <a:xfrm>
+            <a:off x="5486400" y="5797296"/>
+            <a:ext cx="6263640" cy="457200"/>
+          </a:xfrm>
+          <a:prstGeom prst="rect">
+            <a:avLst/>
+          </a:prstGeom>
+          <a:noFill/>
+        </p:spPr>
+        <p:txBody>
+          <a:bodyPr wrap="square" anchor="t" lIns="25400" rIns="25400" tIns="25400" bIns="25400">
+            <a:spAutoFit/>
+          </a:bodyPr>
+          <a:lstStyle/>
+          <a:p>
+            <a:pPr algn="ctr">
+              <a:spcAft>
+                <a:spcPts val="600"/>
+              </a:spcAft>
+            </a:pPr>
+            <a:r>
+              <a:rPr sz="1200" b="0">
+                <a:solidFill>
+                  <a:srgbClr val="6B7280"/>
+                </a:solidFill>
+                <a:latin typeface="Microsoft YaHei"/>
+                <a:ea typeface="Microsoft YaHei"/>
+                <a:cs typeface="Microsoft YaHei"/>
+              </a:rPr>
+              <a:t>图 4 · 层次化分块布图：紧凑块边界 b1–b11 + B*-tree 表示</a:t>
+            </a:r>
+          </a:p>
+        </p:txBody>
+      </p:sp>
+      <p:sp>
+        <p:nvSpPr>
+          <p:cNvPr id="8" name="TextBox 7"/>
+          <p:cNvSpPr txBox="1"/>
+          <p:nvPr/>
+        </p:nvSpPr>
+        <p:spPr>
+          <a:xfrm>
+            <a:off x="5486400" y="6272784"/>
+            <a:ext cx="6263640" cy="274320"/>
+          </a:xfrm>
+          <a:prstGeom prst="rect">
+            <a:avLst/>
+          </a:prstGeom>
+          <a:noFill/>
+        </p:spPr>
+        <p:txBody>
+          <a:bodyPr wrap="square" anchor="t" lIns="25400" rIns="25400" tIns="25400" bIns="25400">
+            <a:spAutoFit/>
+          </a:bodyPr>
+          <a:lstStyle/>
+          <a:p>
+            <a:pPr algn="r">
+              <a:spcAft>
+                <a:spcPts val="600"/>
+              </a:spcAft>
+            </a:pPr>
+            <a:r>
+              <a:rPr sz="900" b="0">
+                <a:solidFill>
+                  <a:srgbClr val="6B7280"/>
+                </a:solidFill>
+                <a:latin typeface="Microsoft YaHei"/>
+                <a:ea typeface="Microsoft YaHei"/>
+                <a:cs typeface="Microsoft YaHei"/>
+              </a:rPr>
+              <a:t>来源：PARSAC, Mostafa et al. · arXiv:2405.05495 · CC BY-SA 4.0</a:t>
+            </a:r>
+          </a:p>
+        </p:txBody>
+      </p:sp>
+      <p:sp>
+        <p:nvSpPr>
+          <p:cNvPr id="9" name="TextBox 8"/>
           <p:cNvSpPr txBox="1"/>
           <p:nvPr/>
         </p:nvSpPr>
@@ -7028,7 +7381,7 @@
           <a:lstStyle/>
           <a:p>
             <a:pPr algn="r"/>
-            <a:fld id="{B79FCC7F-B67F-471B-9628-72121FAE80FC}" type="slidenum">
+            <a:fld id="{B4A8F56D-E473-43B4-A600-9E2B609FE689}" type="slidenum">
               <a:rPr lang="en-US" sz="1000">
                 <a:solidFill>
                   <a:srgbClr val="9AA3B0"/>
@@ -7943,7 +8296,7 @@
           <a:lstStyle/>
           <a:p>
             <a:pPr algn="r"/>
-            <a:fld id="{D03DBFA8-BB6A-4563-BF98-066FB1D27943}" type="slidenum">
+            <a:fld id="{9610426D-1B53-4898-B8C2-BEDFBC408AA1}" type="slidenum">
               <a:rPr lang="en-US" sz="1000">
                 <a:solidFill>
                   <a:srgbClr val="9AA3B0"/>
@@ -8214,7 +8567,7 @@
         </p:nvSpPr>
         <p:spPr>
           <a:xfrm>
-            <a:off x="5486400" y="6382512"/>
+            <a:off x="5486400" y="6272784"/>
             <a:ext cx="6263640" cy="274320"/>
           </a:xfrm>
           <a:prstGeom prst="rect">
@@ -8270,7 +8623,7 @@
           <a:lstStyle/>
           <a:p>
             <a:pPr algn="r"/>
-            <a:fld id="{5DAC4248-A2CD-49B4-97D9-EE00592469BF}" type="slidenum">
+            <a:fld id="{C8067787-3D8A-4A1D-BC57-97543EFE8AD8}" type="slidenum">
               <a:rPr lang="en-US" sz="1000">
                 <a:solidFill>
                   <a:srgbClr val="9AA3B0"/>
@@ -9458,7 +9811,7 @@
         </p:nvSpPr>
         <p:spPr>
           <a:xfrm>
-            <a:off x="5486400" y="6382512"/>
+            <a:off x="5486400" y="6272784"/>
             <a:ext cx="6263640" cy="274320"/>
           </a:xfrm>
           <a:prstGeom prst="rect">
@@ -9514,7 +9867,7 @@
           <a:lstStyle/>
           <a:p>
             <a:pPr algn="r"/>
-            <a:fld id="{150CD64C-9BA4-45E2-BD6E-A3A64EAA5185}" type="slidenum">
+            <a:fld id="{3387B54A-5FF4-473D-9E9D-E3CE6420B745}" type="slidenum">
               <a:rPr lang="en-US" sz="1000">
                 <a:solidFill>
                   <a:srgbClr val="9AA3B0"/>
@@ -9785,7 +10138,7 @@
         </p:nvSpPr>
         <p:spPr>
           <a:xfrm>
-            <a:off x="5486400" y="6382512"/>
+            <a:off x="5486400" y="6272784"/>
             <a:ext cx="6263640" cy="274320"/>
           </a:xfrm>
           <a:prstGeom prst="rect">
@@ -9841,7 +10194,7 @@
           <a:lstStyle/>
           <a:p>
             <a:pPr algn="r"/>
-            <a:fld id="{EFED2FEB-97DE-42FC-9067-3D84FE831C0F}" type="slidenum">
+            <a:fld id="{7BE0B6E9-99BD-4962-9B6E-C5D67E6CE851}" type="slidenum">
               <a:rPr lang="en-US" sz="1000">
                 <a:solidFill>
                   <a:srgbClr val="9AA3B0"/>
@@ -10189,7 +10542,7 @@
           <a:lstStyle/>
           <a:p>
             <a:pPr algn="r"/>
-            <a:fld id="{BD918C2C-03E4-4FD3-AF0F-47D8E0F2A300}" type="slidenum">
+            <a:fld id="{EEB9E5CE-35F5-4542-B9A4-B4BD09DBC2D4}" type="slidenum">
               <a:rPr lang="en-US" sz="1000">
                 <a:solidFill>
                   <a:srgbClr val="9AA3B0"/>
@@ -11077,7 +11430,7 @@
           <a:lstStyle/>
           <a:p>
             <a:pPr algn="r"/>
-            <a:fld id="{5AB9D1F9-209F-4FA5-B9B2-313428FDA173}" type="slidenum">
+            <a:fld id="{E51254B8-9E60-4C7A-BCE1-2F092A3408EE}" type="slidenum">
               <a:rPr lang="en-US" sz="1000">
                 <a:solidFill>
                   <a:srgbClr val="9AA3B0"/>
@@ -12239,7 +12592,7 @@
           <a:lstStyle/>
           <a:p>
             <a:pPr algn="r"/>
-            <a:fld id="{D6759BC0-5E36-40D0-BFC1-6D8002376A63}" type="slidenum">
+            <a:fld id="{4C5BB820-CA2F-4387-8129-7D6EEB59EE3A}" type="slidenum">
               <a:rPr lang="en-US" sz="1000">
                 <a:solidFill>
                   <a:srgbClr val="9AA3B0"/>
@@ -12564,7 +12917,7 @@
           <a:lstStyle/>
           <a:p>
             <a:pPr algn="r"/>
-            <a:fld id="{58BDEFD6-8396-4FF9-ACF7-4439AB0D9084}" type="slidenum">
+            <a:fld id="{C21E8C75-0B9D-4722-A2CB-31117B6B2106}" type="slidenum">
               <a:rPr lang="en-US" sz="1000">
                 <a:solidFill>
                   <a:srgbClr val="9AA3B0"/>
@@ -12913,7 +13266,7 @@
           <a:lstStyle/>
           <a:p>
             <a:pPr algn="r"/>
-            <a:fld id="{5C384DAF-1907-49A3-80CA-3BB7958EBB6B}" type="slidenum">
+            <a:fld id="{42EA8424-91A7-45A9-8F74-9A3E3F486E24}" type="slidenum">
               <a:rPr lang="en-US" sz="1000">
                 <a:solidFill>
                   <a:srgbClr val="9AA3B0"/>
@@ -15005,7 +15358,7 @@
           <a:lstStyle/>
           <a:p>
             <a:pPr algn="r"/>
-            <a:fld id="{E9DB13BF-8425-436A-B03D-2A7EBC4F81C1}" type="slidenum">
+            <a:fld id="{712DFA13-B422-49E1-B801-7C062F77D6AA}" type="slidenum">
               <a:rPr lang="en-US" sz="1000">
                 <a:solidFill>
                   <a:srgbClr val="9AA3B0"/>
@@ -16030,7 +16383,7 @@
           <a:lstStyle/>
           <a:p>
             <a:pPr algn="r"/>
-            <a:fld id="{862D3ACA-4FFB-4DA2-A17F-4D03F7CAA875}" type="slidenum">
+            <a:fld id="{0E0AFCAD-0CBA-498B-A846-AD9420A3583A}" type="slidenum">
               <a:rPr lang="en-US" sz="1000">
                 <a:solidFill>
                   <a:srgbClr val="9AA3B0"/>
@@ -16808,7 +17161,7 @@
           <a:lstStyle/>
           <a:p>
             <a:pPr algn="r"/>
-            <a:fld id="{F43C85B6-972E-4E85-9A11-567488B7E6EF}" type="slidenum">
+            <a:fld id="{5B341CD0-8EB6-4BA1-8B8A-F3C7AED4147C}" type="slidenum">
               <a:rPr lang="en-US" sz="1000">
                 <a:solidFill>
                   <a:srgbClr val="9AA3B0"/>
@@ -16915,7 +17268,7 @@
                 <a:ea typeface="Microsoft YaHei"/>
                 <a:cs typeface="Microsoft YaHei"/>
               </a:rPr>
-              <a:t>本讲内容与图示来源</a:t>
+              <a:t>本讲内容来源</a:t>
             </a:r>
           </a:p>
         </p:txBody>
@@ -16970,7 +17323,7 @@
         <p:spPr>
           <a:xfrm>
             <a:off x="640080" y="1627632"/>
-            <a:ext cx="5486400" cy="4754880"/>
+            <a:ext cx="10972800" cy="4754880"/>
           </a:xfrm>
           <a:prstGeom prst="rect">
             <a:avLst/>
@@ -16985,14 +17338,14 @@
           <a:p>
             <a:pPr algn="l">
               <a:lnSpc>
-                <a:spcPct val="118000"/>
+                <a:spcPct val="120000"/>
               </a:lnSpc>
               <a:spcAft>
-                <a:spcPts val="800"/>
-              </a:spcAft>
-            </a:pPr>
-            <a:r>
-              <a:rPr sz="1200" b="0">
+                <a:spcPts val="900"/>
+              </a:spcAft>
+            </a:pPr>
+            <a:r>
+              <a:rPr sz="1250" b="0">
                 <a:solidFill>
                   <a:srgbClr val="1A1F2B"/>
                 </a:solidFill>
@@ -17006,14 +17359,14 @@
           <a:p>
             <a:pPr algn="l">
               <a:lnSpc>
-                <a:spcPct val="118000"/>
+                <a:spcPct val="120000"/>
               </a:lnSpc>
               <a:spcAft>
-                <a:spcPts val="800"/>
-              </a:spcAft>
-            </a:pPr>
-            <a:r>
-              <a:rPr sz="1200" b="0">
+                <a:spcPts val="900"/>
+              </a:spcAft>
+            </a:pPr>
+            <a:r>
+              <a:rPr sz="1250" b="0">
                 <a:solidFill>
                   <a:srgbClr val="1A1F2B"/>
                 </a:solidFill>
@@ -17027,14 +17380,14 @@
           <a:p>
             <a:pPr algn="l">
               <a:lnSpc>
-                <a:spcPct val="118000"/>
+                <a:spcPct val="120000"/>
               </a:lnSpc>
               <a:spcAft>
-                <a:spcPts val="800"/>
-              </a:spcAft>
-            </a:pPr>
-            <a:r>
-              <a:rPr sz="1200" b="0">
+                <a:spcPts val="900"/>
+              </a:spcAft>
+            </a:pPr>
+            <a:r>
+              <a:rPr sz="1250" b="0">
                 <a:solidFill>
                   <a:srgbClr val="1A1F2B"/>
                 </a:solidFill>
@@ -17048,14 +17401,14 @@
           <a:p>
             <a:pPr algn="l">
               <a:lnSpc>
-                <a:spcPct val="118000"/>
+                <a:spcPct val="120000"/>
               </a:lnSpc>
               <a:spcAft>
-                <a:spcPts val="800"/>
-              </a:spcAft>
-            </a:pPr>
-            <a:r>
-              <a:rPr sz="1200" b="0">
+                <a:spcPts val="900"/>
+              </a:spcAft>
+            </a:pPr>
+            <a:r>
+              <a:rPr sz="1250" b="0">
                 <a:solidFill>
                   <a:srgbClr val="1A1F2B"/>
                 </a:solidFill>
@@ -17069,14 +17422,14 @@
           <a:p>
             <a:pPr algn="l">
               <a:lnSpc>
-                <a:spcPct val="118000"/>
+                <a:spcPct val="120000"/>
               </a:lnSpc>
               <a:spcAft>
-                <a:spcPts val="800"/>
-              </a:spcAft>
-            </a:pPr>
-            <a:r>
-              <a:rPr sz="1200" b="0">
+                <a:spcPts val="900"/>
+              </a:spcAft>
+            </a:pPr>
+            <a:r>
+              <a:rPr sz="1250" b="0">
                 <a:solidFill>
                   <a:srgbClr val="1A1F2B"/>
                 </a:solidFill>
@@ -17092,134 +17445,6 @@
       <p:sp>
         <p:nvSpPr>
           <p:cNvPr id="6" name="TextBox 5"/>
-          <p:cNvSpPr txBox="1"/>
-          <p:nvPr/>
-        </p:nvSpPr>
-        <p:spPr>
-          <a:xfrm>
-            <a:off x="6309360" y="1627632"/>
-            <a:ext cx="5486400" cy="4754880"/>
-          </a:xfrm>
-          <a:prstGeom prst="rect">
-            <a:avLst/>
-          </a:prstGeom>
-          <a:noFill/>
-        </p:spPr>
-        <p:txBody>
-          <a:bodyPr wrap="square" anchor="t" lIns="25400" rIns="25400" tIns="25400" bIns="25400">
-            <a:normAutofit/>
-          </a:bodyPr>
-          <a:lstStyle/>
-          <a:p>
-            <a:pPr algn="l">
-              <a:lnSpc>
-                <a:spcPct val="118000"/>
-              </a:lnSpc>
-              <a:spcAft>
-                <a:spcPts val="800"/>
-              </a:spcAft>
-            </a:pPr>
-            <a:r>
-              <a:rPr sz="1200" b="0">
-                <a:solidFill>
-                  <a:srgbClr val="1A1F2B"/>
-                </a:solidFill>
-                <a:latin typeface="Microsoft YaHei"/>
-                <a:ea typeface="Microsoft YaHei"/>
-                <a:cs typeface="Microsoft YaHei"/>
-              </a:rPr>
-              <a:t>[6]  图 1.1 Intel 80486DX2 die — Smial, CC BY 3.0, Wikimedia Commons.</a:t>
-            </a:r>
-          </a:p>
-          <a:p>
-            <a:pPr algn="l">
-              <a:lnSpc>
-                <a:spcPct val="118000"/>
-              </a:lnSpc>
-              <a:spcAft>
-                <a:spcPts val="800"/>
-              </a:spcAft>
-            </a:pPr>
-            <a:r>
-              <a:rPr sz="1200" b="0">
-                <a:solidFill>
-                  <a:srgbClr val="1A1F2B"/>
-                </a:solidFill>
-                <a:latin typeface="Microsoft YaHei"/>
-                <a:ea typeface="Microsoft YaHei"/>
-                <a:cs typeface="Microsoft YaHei"/>
-              </a:rPr>
-              <a:t>[7]  图 2.1 Intel Core i9-13900K die shot — Fritzchens Fritz / JmsDoug, CC0, Wikimedia Commons.</a:t>
-            </a:r>
-          </a:p>
-          <a:p>
-            <a:pPr algn="l">
-              <a:lnSpc>
-                <a:spcPct val="118000"/>
-              </a:lnSpc>
-              <a:spcAft>
-                <a:spcPts val="800"/>
-              </a:spcAft>
-            </a:pPr>
-            <a:r>
-              <a:rPr sz="1200" b="0">
-                <a:solidFill>
-                  <a:srgbClr val="1A1F2B"/>
-                </a:solidFill>
-                <a:latin typeface="Microsoft YaHei"/>
-                <a:ea typeface="Microsoft YaHei"/>
-                <a:cs typeface="Microsoft YaHei"/>
-              </a:rPr>
-              <a:t>[8]  图 3.3 Wire-bonding close-up — Mister rf, CC BY-SA 4.0, Wikimedia Commons.</a:t>
-            </a:r>
-          </a:p>
-          <a:p>
-            <a:pPr algn="l">
-              <a:lnSpc>
-                <a:spcPct val="118000"/>
-              </a:lnSpc>
-              <a:spcAft>
-                <a:spcPts val="800"/>
-              </a:spcAft>
-            </a:pPr>
-            <a:r>
-              <a:rPr sz="1200" b="0">
-                <a:solidFill>
-                  <a:srgbClr val="1A1F2B"/>
-                </a:solidFill>
-                <a:latin typeface="Microsoft YaHei"/>
-                <a:ea typeface="Microsoft YaHei"/>
-                <a:cs typeface="Microsoft YaHei"/>
-              </a:rPr>
-              <a:t>[9]  图 4.1 Bitfury 顶层金属供电网 — ZeptoBars, CC BY 3.0, Wikimedia Commons.</a:t>
-            </a:r>
-          </a:p>
-          <a:p>
-            <a:pPr algn="l">
-              <a:lnSpc>
-                <a:spcPct val="118000"/>
-              </a:lnSpc>
-              <a:spcAft>
-                <a:spcPts val="800"/>
-              </a:spcAft>
-            </a:pPr>
-            <a:r>
-              <a:rPr sz="1200" b="0">
-                <a:solidFill>
-                  <a:srgbClr val="1A1F2B"/>
-                </a:solidFill>
-                <a:latin typeface="Microsoft YaHei"/>
-                <a:ea typeface="Microsoft YaHei"/>
-                <a:cs typeface="Microsoft YaHei"/>
-              </a:rPr>
-              <a:t>[10]  图 4.2 Static IR-drop map — Seo et al. (WACA-UNet), arXiv:2507.19197, CC BY 4.0.</a:t>
-            </a:r>
-          </a:p>
-        </p:txBody>
-      </p:sp>
-      <p:sp>
-        <p:nvSpPr>
-          <p:cNvPr id="7" name="TextBox 6"/>
           <p:cNvSpPr txBox="1"/>
           <p:nvPr/>
         </p:nvSpPr>
@@ -17240,7 +17465,7 @@
           <a:lstStyle/>
           <a:p>
             <a:pPr algn="r"/>
-            <a:fld id="{B8A48CF9-80C1-403A-8FA5-6494CD0EE803}" type="slidenum">
+            <a:fld id="{D7C1414F-638A-4358-97FC-48E0B6CC3565}" type="slidenum">
               <a:rPr lang="en-US" sz="1000">
                 <a:solidFill>
                   <a:srgbClr val="9AA3B0"/>
@@ -17261,6 +17486,417 @@
 </file>
 
 <file path=ppt/slides/slide34.xml><?xml version="1.0" encoding="utf-8"?>
+<p:sld xmlns:a="http://schemas.openxmlformats.org/drawingml/2006/main" xmlns:p="http://schemas.openxmlformats.org/presentationml/2006/main" xmlns:r="http://schemas.openxmlformats.org/officeDocument/2006/relationships">
+  <p:cSld>
+    <p:spTree>
+      <p:nvGrpSpPr>
+        <p:cNvPr id="1" name=""/>
+        <p:cNvGrpSpPr/>
+        <p:nvPr/>
+      </p:nvGrpSpPr>
+      <p:grpSpPr/>
+      <p:sp>
+        <p:nvSpPr>
+          <p:cNvPr id="2" name="TextBox 1"/>
+          <p:cNvSpPr txBox="1"/>
+          <p:nvPr/>
+        </p:nvSpPr>
+        <p:spPr>
+          <a:xfrm>
+            <a:off x="777240" y="384048"/>
+            <a:ext cx="8412480" cy="731520"/>
+          </a:xfrm>
+          <a:prstGeom prst="rect">
+            <a:avLst/>
+          </a:prstGeom>
+          <a:noFill/>
+        </p:spPr>
+        <p:txBody>
+          <a:bodyPr wrap="square" anchor="t" lIns="25400" rIns="25400" tIns="25400" bIns="25400">
+            <a:spAutoFit/>
+          </a:bodyPr>
+          <a:lstStyle/>
+          <a:p>
+            <a:pPr algn="l">
+              <a:spcAft>
+                <a:spcPts val="600"/>
+              </a:spcAft>
+            </a:pPr>
+            <a:r>
+              <a:rPr sz="2800" b="1">
+                <a:solidFill>
+                  <a:srgbClr val="1A1F2B"/>
+                </a:solidFill>
+                <a:latin typeface="Microsoft YaHei"/>
+                <a:ea typeface="Microsoft YaHei"/>
+                <a:cs typeface="Microsoft YaHei"/>
+              </a:rPr>
+              <a:t>图片来源 Image Credits</a:t>
+            </a:r>
+          </a:p>
+        </p:txBody>
+      </p:sp>
+      <p:sp>
+        <p:nvSpPr>
+          <p:cNvPr id="3" name="TextBox 2"/>
+          <p:cNvSpPr txBox="1"/>
+          <p:nvPr/>
+        </p:nvSpPr>
+        <p:spPr>
+          <a:xfrm>
+            <a:off x="795528" y="1078992"/>
+            <a:ext cx="8412480" cy="457200"/>
+          </a:xfrm>
+          <a:prstGeom prst="rect">
+            <a:avLst/>
+          </a:prstGeom>
+          <a:noFill/>
+        </p:spPr>
+        <p:txBody>
+          <a:bodyPr wrap="square" anchor="t" lIns="25400" rIns="25400" tIns="25400" bIns="25400">
+            <a:spAutoFit/>
+          </a:bodyPr>
+          <a:lstStyle/>
+          <a:p>
+            <a:pPr algn="l">
+              <a:spcAft>
+                <a:spcPts val="600"/>
+              </a:spcAft>
+            </a:pPr>
+            <a:r>
+              <a:rPr sz="1400" b="0">
+                <a:solidFill>
+                  <a:srgbClr val="3A4252"/>
+                </a:solidFill>
+                <a:latin typeface="Microsoft YaHei"/>
+                <a:ea typeface="Microsoft YaHei"/>
+                <a:cs typeface="Microsoft YaHei"/>
+              </a:rPr>
+              <a:t>全部为开放许可（CC0 / CC BY / CC BY-SA / 公有领域），均经来源页核验、按许可署名</a:t>
+            </a:r>
+          </a:p>
+        </p:txBody>
+      </p:sp>
+      <p:sp>
+        <p:nvSpPr>
+          <p:cNvPr id="4" name="TextBox 3"/>
+          <p:cNvSpPr txBox="1"/>
+          <p:nvPr/>
+        </p:nvSpPr>
+        <p:spPr>
+          <a:xfrm>
+            <a:off x="8549640" y="502920"/>
+            <a:ext cx="3063240" cy="365760"/>
+          </a:xfrm>
+          <a:prstGeom prst="rect">
+            <a:avLst/>
+          </a:prstGeom>
+          <a:noFill/>
+        </p:spPr>
+        <p:txBody>
+          <a:bodyPr wrap="square" anchor="t" lIns="25400" rIns="25400" tIns="25400" bIns="25400">
+            <a:spAutoFit/>
+          </a:bodyPr>
+          <a:lstStyle/>
+          <a:p>
+            <a:pPr algn="r">
+              <a:spcAft>
+                <a:spcPts val="600"/>
+              </a:spcAft>
+            </a:pPr>
+            <a:r>
+              <a:rPr sz="1200" b="1">
+                <a:solidFill>
+                  <a:srgbClr val="46196B"/>
+                </a:solidFill>
+                <a:latin typeface="Microsoft YaHei"/>
+                <a:ea typeface="Microsoft YaHei"/>
+                <a:cs typeface="Microsoft YaHei"/>
+              </a:rPr>
+              <a:t>第5章 · 工具流程与调试收束</a:t>
+            </a:r>
+          </a:p>
+        </p:txBody>
+      </p:sp>
+      <p:sp>
+        <p:nvSpPr>
+          <p:cNvPr id="5" name="TextBox 4"/>
+          <p:cNvSpPr txBox="1"/>
+          <p:nvPr/>
+        </p:nvSpPr>
+        <p:spPr>
+          <a:xfrm>
+            <a:off x="640080" y="1627632"/>
+            <a:ext cx="5486400" cy="4754880"/>
+          </a:xfrm>
+          <a:prstGeom prst="rect">
+            <a:avLst/>
+          </a:prstGeom>
+          <a:noFill/>
+        </p:spPr>
+        <p:txBody>
+          <a:bodyPr wrap="square" anchor="t" lIns="25400" rIns="25400" tIns="25400" bIns="25400">
+            <a:normAutofit/>
+          </a:bodyPr>
+          <a:lstStyle/>
+          <a:p>
+            <a:pPr algn="l">
+              <a:lnSpc>
+                <a:spcPct val="118000"/>
+              </a:lnSpc>
+              <a:spcAft>
+                <a:spcPts val="800"/>
+              </a:spcAft>
+            </a:pPr>
+            <a:r>
+              <a:rPr sz="1200" b="0">
+                <a:solidFill>
+                  <a:srgbClr val="1A1F2B"/>
+                </a:solidFill>
+                <a:latin typeface="Microsoft YaHei"/>
+                <a:ea typeface="Microsoft YaHei"/>
+                <a:cs typeface="Microsoft YaHei"/>
+              </a:rPr>
+              <a:t>[1]  图 1.1 Intel 80486DX2 die（功能块标注）— Smial, CC BY 3.0, Wikimedia Commons.</a:t>
+            </a:r>
+          </a:p>
+          <a:p>
+            <a:pPr algn="l">
+              <a:lnSpc>
+                <a:spcPct val="118000"/>
+              </a:lnSpc>
+              <a:spcAft>
+                <a:spcPts val="800"/>
+              </a:spcAft>
+            </a:pPr>
+            <a:r>
+              <a:rPr sz="1200" b="0">
+                <a:solidFill>
+                  <a:srgbClr val="1A1F2B"/>
+                </a:solidFill>
+                <a:latin typeface="Microsoft YaHei"/>
+                <a:ea typeface="Microsoft YaHei"/>
+                <a:cs typeface="Microsoft YaHei"/>
+              </a:rPr>
+              <a:t>[2]  图 2.1 Intel Core i9-13900K die shot — Fritzchens Fritz / JmsDoug, CC0, Wikimedia Commons.</a:t>
+            </a:r>
+          </a:p>
+          <a:p>
+            <a:pPr algn="l">
+              <a:lnSpc>
+                <a:spcPct val="118000"/>
+              </a:lnSpc>
+              <a:spcAft>
+                <a:spcPts val="800"/>
+              </a:spcAft>
+            </a:pPr>
+            <a:r>
+              <a:rPr sz="1200" b="0">
+                <a:solidFill>
+                  <a:srgbClr val="1A1F2B"/>
+                </a:solidFill>
+                <a:latin typeface="Microsoft YaHei"/>
+                <a:ea typeface="Microsoft YaHei"/>
+                <a:cs typeface="Microsoft YaHei"/>
+              </a:rPr>
+              <a:t>[3]  图 2.2 布线拥塞形成（VeriHGN）— R. Hu et al., arXiv:2603.11075, doi:10.48550/arXiv.2603.11075, CC BY 4.0.</a:t>
+            </a:r>
+          </a:p>
+          <a:p>
+            <a:pPr algn="l">
+              <a:lnSpc>
+                <a:spcPct val="118000"/>
+              </a:lnSpc>
+              <a:spcAft>
+                <a:spcPts val="800"/>
+              </a:spcAft>
+            </a:pPr>
+            <a:r>
+              <a:rPr sz="1200" b="0">
+                <a:solidFill>
+                  <a:srgbClr val="1A1F2B"/>
+                </a:solidFill>
+                <a:latin typeface="Microsoft YaHei"/>
+                <a:ea typeface="Microsoft YaHei"/>
+                <a:cs typeface="Microsoft YaHei"/>
+              </a:rPr>
+              <a:t>[4]  图 2.4 UltraSPARC T1 die（核 + L2 存储宏）— ZyMOS / Fritzchens Fritz, CC BY-SA 3.0, Wikimedia Commons.</a:t>
+            </a:r>
+          </a:p>
+          <a:p>
+            <a:pPr algn="l">
+              <a:lnSpc>
+                <a:spcPct val="118000"/>
+              </a:lnSpc>
+              <a:spcAft>
+                <a:spcPts val="800"/>
+              </a:spcAft>
+            </a:pPr>
+            <a:r>
+              <a:rPr sz="1200" b="0">
+                <a:solidFill>
+                  <a:srgbClr val="1A1F2B"/>
+                </a:solidFill>
+                <a:latin typeface="Microsoft YaHei"/>
+                <a:ea typeface="Microsoft YaHei"/>
+                <a:cs typeface="Microsoft YaHei"/>
+              </a:rPr>
+              <a:t>[5]  图 2.4 宏摆放对比（人工 vs 规则 AI）— Copparihollmann, CC BY-SA 4.0, Wikimedia Commons.</a:t>
+            </a:r>
+          </a:p>
+        </p:txBody>
+      </p:sp>
+      <p:sp>
+        <p:nvSpPr>
+          <p:cNvPr id="6" name="TextBox 5"/>
+          <p:cNvSpPr txBox="1"/>
+          <p:nvPr/>
+        </p:nvSpPr>
+        <p:spPr>
+          <a:xfrm>
+            <a:off x="6309360" y="1627632"/>
+            <a:ext cx="5486400" cy="4754880"/>
+          </a:xfrm>
+          <a:prstGeom prst="rect">
+            <a:avLst/>
+          </a:prstGeom>
+          <a:noFill/>
+        </p:spPr>
+        <p:txBody>
+          <a:bodyPr wrap="square" anchor="t" lIns="25400" rIns="25400" tIns="25400" bIns="25400">
+            <a:normAutofit/>
+          </a:bodyPr>
+          <a:lstStyle/>
+          <a:p>
+            <a:pPr algn="l">
+              <a:lnSpc>
+                <a:spcPct val="118000"/>
+              </a:lnSpc>
+              <a:spcAft>
+                <a:spcPts val="800"/>
+              </a:spcAft>
+            </a:pPr>
+            <a:r>
+              <a:rPr sz="1200" b="0">
+                <a:solidFill>
+                  <a:srgbClr val="1A1F2B"/>
+                </a:solidFill>
+                <a:latin typeface="Microsoft YaHei"/>
+                <a:ea typeface="Microsoft YaHei"/>
+                <a:cs typeface="Microsoft YaHei"/>
+              </a:rPr>
+              <a:t>[6]  图 3.2 层次化分块布图（PARSAC）— H. Mostafa et al., arXiv:2405.05495, doi:10.48550/arXiv.2405.05495, CC BY-SA 4.0.</a:t>
+            </a:r>
+          </a:p>
+          <a:p>
+            <a:pPr algn="l">
+              <a:lnSpc>
+                <a:spcPct val="118000"/>
+              </a:lnSpc>
+              <a:spcAft>
+                <a:spcPts val="800"/>
+              </a:spcAft>
+            </a:pPr>
+            <a:r>
+              <a:rPr sz="1200" b="0">
+                <a:solidFill>
+                  <a:srgbClr val="1A1F2B"/>
+                </a:solidFill>
+                <a:latin typeface="Microsoft YaHei"/>
+                <a:ea typeface="Microsoft YaHei"/>
+                <a:cs typeface="Microsoft YaHei"/>
+              </a:rPr>
+              <a:t>[7]  图 3.3 Wire-bonding close-up — Mister rf, CC BY-SA 4.0, Wikimedia Commons.</a:t>
+            </a:r>
+          </a:p>
+          <a:p>
+            <a:pPr algn="l">
+              <a:lnSpc>
+                <a:spcPct val="118000"/>
+              </a:lnSpc>
+              <a:spcAft>
+                <a:spcPts val="800"/>
+              </a:spcAft>
+            </a:pPr>
+            <a:r>
+              <a:rPr sz="1200" b="0">
+                <a:solidFill>
+                  <a:srgbClr val="1A1F2B"/>
+                </a:solidFill>
+                <a:latin typeface="Microsoft YaHei"/>
+                <a:ea typeface="Microsoft YaHei"/>
+                <a:cs typeface="Microsoft YaHei"/>
+              </a:rPr>
+              <a:t>[8]  图 4.1 Bitfury 芯片顶层金属供电网 — ZeptoBars, CC BY 3.0, Wikimedia Commons.</a:t>
+            </a:r>
+          </a:p>
+          <a:p>
+            <a:pPr algn="l">
+              <a:lnSpc>
+                <a:spcPct val="118000"/>
+              </a:lnSpc>
+              <a:spcAft>
+                <a:spcPts val="800"/>
+              </a:spcAft>
+            </a:pPr>
+            <a:r>
+              <a:rPr sz="1200" b="0">
+                <a:solidFill>
+                  <a:srgbClr val="1A1F2B"/>
+                </a:solidFill>
+                <a:latin typeface="Microsoft YaHei"/>
+                <a:ea typeface="Microsoft YaHei"/>
+                <a:cs typeface="Microsoft YaHei"/>
+              </a:rPr>
+              <a:t>[9]  图 4.2 Static IR-drop map（WACA-UNet）— Y. Seo et al., arXiv:2507.19197, doi:10.48550/arXiv.2507.19197, CC BY 4.0.</a:t>
+            </a:r>
+          </a:p>
+        </p:txBody>
+      </p:sp>
+      <p:sp>
+        <p:nvSpPr>
+          <p:cNvPr id="7" name="TextBox 6"/>
+          <p:cNvSpPr txBox="1"/>
+          <p:nvPr/>
+        </p:nvSpPr>
+        <p:spPr>
+          <a:xfrm>
+            <a:off x="9875520" y="6446520"/>
+            <a:ext cx="2011680" cy="365760"/>
+          </a:xfrm>
+          <a:prstGeom prst="rect">
+            <a:avLst/>
+          </a:prstGeom>
+          <a:noFill/>
+        </p:spPr>
+        <p:txBody>
+          <a:bodyPr wrap="none" lIns="0" rIns="0" tIns="0" bIns="0">
+            <a:spAutoFit/>
+          </a:bodyPr>
+          <a:lstStyle/>
+          <a:p>
+            <a:pPr algn="r"/>
+            <a:fld id="{51EAA231-076E-48C6-B018-8893BECBD70E}" type="slidenum">
+              <a:rPr lang="en-US" sz="1000">
+                <a:solidFill>
+                  <a:srgbClr val="9AA3B0"/>
+                </a:solidFill>
+                <a:latin typeface="Microsoft YaHei"/>
+              </a:rPr>
+              <a:t>1</a:t>
+            </a:fld>
+          </a:p>
+        </p:txBody>
+      </p:sp>
+    </p:spTree>
+  </p:cSld>
+  <p:clrMapOvr>
+    <a:masterClrMapping/>
+  </p:clrMapOvr>
+</p:sld>
+</file>
+
+<file path=ppt/slides/slide35.xml><?xml version="1.0" encoding="utf-8"?>
 <p:sld xmlns:a="http://schemas.openxmlformats.org/drawingml/2006/main" xmlns:p="http://schemas.openxmlformats.org/presentationml/2006/main" xmlns:r="http://schemas.openxmlformats.org/officeDocument/2006/relationships">
   <p:cSld>
     <p:bg>
@@ -17896,7 +18532,7 @@
         </p:nvSpPr>
         <p:spPr>
           <a:xfrm>
-            <a:off x="5486400" y="6382512"/>
+            <a:off x="5486400" y="6272784"/>
             <a:ext cx="6263640" cy="274320"/>
           </a:xfrm>
           <a:prstGeom prst="rect">
@@ -17952,7 +18588,7 @@
           <a:lstStyle/>
           <a:p>
             <a:pPr algn="r"/>
-            <a:fld id="{BD9210C9-080A-4EE7-B132-1F339F407D8A}" type="slidenum">
+            <a:fld id="{5BFDD1E6-7C28-47B0-9598-B0D336D56D0E}" type="slidenum">
               <a:rPr lang="en-US" sz="1000">
                 <a:solidFill>
                   <a:srgbClr val="9AA3B0"/>
@@ -18614,7 +19250,7 @@
           <a:lstStyle/>
           <a:p>
             <a:pPr algn="r"/>
-            <a:fld id="{33E3DE75-8222-4E2F-9183-60B209580E96}" type="slidenum">
+            <a:fld id="{5F1525CD-11DC-460F-9A40-79FD025ACD1B}" type="slidenum">
               <a:rPr lang="en-US" sz="1000">
                 <a:solidFill>
                   <a:srgbClr val="9AA3B0"/>
@@ -19720,7 +20356,7 @@
           <a:lstStyle/>
           <a:p>
             <a:pPr algn="r"/>
-            <a:fld id="{EC0696B9-B25B-4DFF-8610-A627F29C962A}" type="slidenum">
+            <a:fld id="{3BA9A727-6370-42B7-9EE6-4E7C9B0056C2}" type="slidenum">
               <a:rPr lang="en-US" sz="1000">
                 <a:solidFill>
                   <a:srgbClr val="9AA3B0"/>
@@ -20750,7 +21386,7 @@
           <a:lstStyle/>
           <a:p>
             <a:pPr algn="r"/>
-            <a:fld id="{7AC00E5B-DDA4-4599-A00E-328CDD540C76}" type="slidenum">
+            <a:fld id="{897FA29C-A791-4955-A45B-6BD8377BA5E8}" type="slidenum">
               <a:rPr lang="en-US" sz="1000">
                 <a:solidFill>
                   <a:srgbClr val="9AA3B0"/>
@@ -21827,7 +22463,7 @@
           <a:lstStyle/>
           <a:p>
             <a:pPr algn="r"/>
-            <a:fld id="{07B92D92-06B8-4F6E-B094-BAC4AE3A21E6}" type="slidenum">
+            <a:fld id="{7D9EF7DF-8617-4EB4-B19D-A6719D8AFC77}" type="slidenum">
               <a:rPr lang="en-US" sz="1000">
                 <a:solidFill>
                   <a:srgbClr val="9AA3B0"/>

</xml_diff>